<commit_message>
Update presentation and add demo video
Replace Final slides (G7).pptx with an updated version and add Video Demo.mp4 to the repository. Includes finalized presentation slides and a new demo video illustrating the project.
</commit_message>
<xml_diff>
--- a/others/Final slides (G7).pptx
+++ b/others/Final slides (G7).pptx
@@ -212,7 +212,7 @@
           </a:lstStyle>
           <a:p>
             <a:fld id="{489D2C63-CB8E-4C69-BFB6-9AC9D8C1CA13}" type="datetimeFigureOut">
-              <a:t>5/4/2026</a:t>
+              <a:t>04-May-26</a:t>
             </a:fld>
             <a:endParaRPr lang="en-US"/>
           </a:p>
@@ -1232,7 +1232,7 @@
           <p:cNvPr id="2" name="Shape 0">
             <a:extLst>
               <a:ext uri="{FF2B5EF4-FFF2-40B4-BE49-F238E27FC236}">
-                <a16:creationId xmlns:a16="http://schemas.microsoft.com/office/drawing/2014/main" id="{07D48B70-643E-5398-0182-63939169A457}"/>
+                <a16:creationId xmlns:a16="http://schemas.microsoft.com/office/drawing/2014/main" xmlns="" id="{07D48B70-643E-5398-0182-63939169A457}"/>
               </a:ext>
             </a:extLst>
           </p:cNvPr>
@@ -1263,7 +1263,7 @@
           <p:cNvPr id="3" name="Shape 1">
             <a:extLst>
               <a:ext uri="{FF2B5EF4-FFF2-40B4-BE49-F238E27FC236}">
-                <a16:creationId xmlns:a16="http://schemas.microsoft.com/office/drawing/2014/main" id="{4574CFF8-DDD8-F038-8C17-129AB18155EF}"/>
+                <a16:creationId xmlns:a16="http://schemas.microsoft.com/office/drawing/2014/main" xmlns="" id="{4574CFF8-DDD8-F038-8C17-129AB18155EF}"/>
               </a:ext>
             </a:extLst>
           </p:cNvPr>
@@ -1297,7 +1297,7 @@
           <p:cNvPr id="4" name="Shape 2">
             <a:extLst>
               <a:ext uri="{FF2B5EF4-FFF2-40B4-BE49-F238E27FC236}">
-                <a16:creationId xmlns:a16="http://schemas.microsoft.com/office/drawing/2014/main" id="{7CD5AEA1-D504-0CA3-4EA4-0978F9FE7805}"/>
+                <a16:creationId xmlns:a16="http://schemas.microsoft.com/office/drawing/2014/main" xmlns="" id="{7CD5AEA1-D504-0CA3-4EA4-0978F9FE7805}"/>
               </a:ext>
             </a:extLst>
           </p:cNvPr>
@@ -1328,7 +1328,7 @@
           <p:cNvPr id="5" name="Shape 3">
             <a:extLst>
               <a:ext uri="{FF2B5EF4-FFF2-40B4-BE49-F238E27FC236}">
-                <a16:creationId xmlns:a16="http://schemas.microsoft.com/office/drawing/2014/main" id="{27857ADF-E943-3CC1-B247-52D96FE7BF83}"/>
+                <a16:creationId xmlns:a16="http://schemas.microsoft.com/office/drawing/2014/main" xmlns="" id="{27857ADF-E943-3CC1-B247-52D96FE7BF83}"/>
               </a:ext>
             </a:extLst>
           </p:cNvPr>
@@ -1359,7 +1359,7 @@
           <p:cNvPr id="6" name="Shape 4">
             <a:extLst>
               <a:ext uri="{FF2B5EF4-FFF2-40B4-BE49-F238E27FC236}">
-                <a16:creationId xmlns:a16="http://schemas.microsoft.com/office/drawing/2014/main" id="{7025232F-30E9-7C9B-D4AE-E64A06388532}"/>
+                <a16:creationId xmlns:a16="http://schemas.microsoft.com/office/drawing/2014/main" xmlns="" id="{7025232F-30E9-7C9B-D4AE-E64A06388532}"/>
               </a:ext>
             </a:extLst>
           </p:cNvPr>
@@ -1397,7 +1397,7 @@
           <p:cNvPr id="7" name="Text 5">
             <a:extLst>
               <a:ext uri="{FF2B5EF4-FFF2-40B4-BE49-F238E27FC236}">
-                <a16:creationId xmlns:a16="http://schemas.microsoft.com/office/drawing/2014/main" id="{04A4207A-655C-C7DE-CCF7-A2F88B8C5478}"/>
+                <a16:creationId xmlns:a16="http://schemas.microsoft.com/office/drawing/2014/main" xmlns="" id="{04A4207A-655C-C7DE-CCF7-A2F88B8C5478}"/>
               </a:ext>
             </a:extLst>
           </p:cNvPr>
@@ -1450,7 +1450,7 @@
           <p:cNvPr id="8" name="Text 6">
             <a:extLst>
               <a:ext uri="{FF2B5EF4-FFF2-40B4-BE49-F238E27FC236}">
-                <a16:creationId xmlns:a16="http://schemas.microsoft.com/office/drawing/2014/main" id="{C94884A8-64C3-2A91-547A-4DCAF760B5FF}"/>
+                <a16:creationId xmlns:a16="http://schemas.microsoft.com/office/drawing/2014/main" xmlns="" id="{C94884A8-64C3-2A91-547A-4DCAF760B5FF}"/>
               </a:ext>
             </a:extLst>
           </p:cNvPr>
@@ -1512,7 +1512,7 @@
           <p:cNvPr id="9" name="Text 7">
             <a:extLst>
               <a:ext uri="{FF2B5EF4-FFF2-40B4-BE49-F238E27FC236}">
-                <a16:creationId xmlns:a16="http://schemas.microsoft.com/office/drawing/2014/main" id="{724CEEA7-46D3-F02E-74B4-62F7BF7F63A6}"/>
+                <a16:creationId xmlns:a16="http://schemas.microsoft.com/office/drawing/2014/main" xmlns="" id="{724CEEA7-46D3-F02E-74B4-62F7BF7F63A6}"/>
               </a:ext>
             </a:extLst>
           </p:cNvPr>
@@ -1567,7 +1567,7 @@
           <p:cNvPr id="10" name="Text 8">
             <a:extLst>
               <a:ext uri="{FF2B5EF4-FFF2-40B4-BE49-F238E27FC236}">
-                <a16:creationId xmlns:a16="http://schemas.microsoft.com/office/drawing/2014/main" id="{F4404318-C77A-05BA-AF98-2E278907F1CD}"/>
+                <a16:creationId xmlns:a16="http://schemas.microsoft.com/office/drawing/2014/main" xmlns="" id="{F4404318-C77A-05BA-AF98-2E278907F1CD}"/>
               </a:ext>
             </a:extLst>
           </p:cNvPr>
@@ -1609,7 +1609,7 @@
           <p:cNvPr id="11" name="Shape 9">
             <a:extLst>
               <a:ext uri="{FF2B5EF4-FFF2-40B4-BE49-F238E27FC236}">
-                <a16:creationId xmlns:a16="http://schemas.microsoft.com/office/drawing/2014/main" id="{9B017DC0-D0EC-4426-3A6C-8F1D5F34C22B}"/>
+                <a16:creationId xmlns:a16="http://schemas.microsoft.com/office/drawing/2014/main" xmlns="" id="{9B017DC0-D0EC-4426-3A6C-8F1D5F34C22B}"/>
               </a:ext>
             </a:extLst>
           </p:cNvPr>
@@ -1646,7 +1646,7 @@
           <p:cNvPr id="12" name="Text 10">
             <a:extLst>
               <a:ext uri="{FF2B5EF4-FFF2-40B4-BE49-F238E27FC236}">
-                <a16:creationId xmlns:a16="http://schemas.microsoft.com/office/drawing/2014/main" id="{FCE5AC94-2920-21F3-9882-3E4528B0DE96}"/>
+                <a16:creationId xmlns:a16="http://schemas.microsoft.com/office/drawing/2014/main" xmlns="" id="{FCE5AC94-2920-21F3-9882-3E4528B0DE96}"/>
               </a:ext>
             </a:extLst>
           </p:cNvPr>
@@ -1688,7 +1688,7 @@
           <p:cNvPr id="13" name="Text 11">
             <a:extLst>
               <a:ext uri="{FF2B5EF4-FFF2-40B4-BE49-F238E27FC236}">
-                <a16:creationId xmlns:a16="http://schemas.microsoft.com/office/drawing/2014/main" id="{ACAAC472-DA27-C564-8F9C-6333BF7E6F28}"/>
+                <a16:creationId xmlns:a16="http://schemas.microsoft.com/office/drawing/2014/main" xmlns="" id="{ACAAC472-DA27-C564-8F9C-6333BF7E6F28}"/>
               </a:ext>
             </a:extLst>
           </p:cNvPr>
@@ -1730,7 +1730,7 @@
           <p:cNvPr id="14" name="Text 12">
             <a:extLst>
               <a:ext uri="{FF2B5EF4-FFF2-40B4-BE49-F238E27FC236}">
-                <a16:creationId xmlns:a16="http://schemas.microsoft.com/office/drawing/2014/main" id="{068C93DC-21C0-A14F-3AE7-AB51A5EE5E2B}"/>
+                <a16:creationId xmlns:a16="http://schemas.microsoft.com/office/drawing/2014/main" xmlns="" id="{068C93DC-21C0-A14F-3AE7-AB51A5EE5E2B}"/>
               </a:ext>
             </a:extLst>
           </p:cNvPr>
@@ -1772,7 +1772,7 @@
           <p:cNvPr id="15" name="Image 0" descr="preencoded.png">
             <a:extLst>
               <a:ext uri="{FF2B5EF4-FFF2-40B4-BE49-F238E27FC236}">
-                <a16:creationId xmlns:a16="http://schemas.microsoft.com/office/drawing/2014/main" id="{2240F1F3-CEA7-CD8E-D86F-7CCBC6A4BD73}"/>
+                <a16:creationId xmlns:a16="http://schemas.microsoft.com/office/drawing/2014/main" xmlns="" id="{2240F1F3-CEA7-CD8E-D86F-7CCBC6A4BD73}"/>
               </a:ext>
             </a:extLst>
           </p:cNvPr>
@@ -1811,7 +1811,7 @@
           <p:cNvPr id="16" name="Shape 13">
             <a:extLst>
               <a:ext uri="{FF2B5EF4-FFF2-40B4-BE49-F238E27FC236}">
-                <a16:creationId xmlns:a16="http://schemas.microsoft.com/office/drawing/2014/main" id="{2463A389-9F67-992B-6DAD-FDB571A10A23}"/>
+                <a16:creationId xmlns:a16="http://schemas.microsoft.com/office/drawing/2014/main" xmlns="" id="{2463A389-9F67-992B-6DAD-FDB571A10A23}"/>
               </a:ext>
             </a:extLst>
           </p:cNvPr>
@@ -1839,7 +1839,7 @@
           <p:cNvPr id="17" name="Image 1" descr="preencoded.png">
             <a:extLst>
               <a:ext uri="{FF2B5EF4-FFF2-40B4-BE49-F238E27FC236}">
-                <a16:creationId xmlns:a16="http://schemas.microsoft.com/office/drawing/2014/main" id="{99EDCC59-7008-EE42-9469-32E7861AE591}"/>
+                <a16:creationId xmlns:a16="http://schemas.microsoft.com/office/drawing/2014/main" xmlns="" id="{99EDCC59-7008-EE42-9469-32E7861AE591}"/>
               </a:ext>
             </a:extLst>
           </p:cNvPr>
@@ -1873,7 +1873,7 @@
           <p:cNvPr id="18" name="Shape 14">
             <a:extLst>
               <a:ext uri="{FF2B5EF4-FFF2-40B4-BE49-F238E27FC236}">
-                <a16:creationId xmlns:a16="http://schemas.microsoft.com/office/drawing/2014/main" id="{A4B4A26E-8DBD-388C-4803-88287B071883}"/>
+                <a16:creationId xmlns:a16="http://schemas.microsoft.com/office/drawing/2014/main" xmlns="" id="{A4B4A26E-8DBD-388C-4803-88287B071883}"/>
               </a:ext>
             </a:extLst>
           </p:cNvPr>
@@ -1901,7 +1901,7 @@
           <p:cNvPr id="26" name="Picture 25">
             <a:extLst>
               <a:ext uri="{FF2B5EF4-FFF2-40B4-BE49-F238E27FC236}">
-                <a16:creationId xmlns:a16="http://schemas.microsoft.com/office/drawing/2014/main" id="{699CC631-D84F-E098-C402-339DDB4E55F9}"/>
+                <a16:creationId xmlns:a16="http://schemas.microsoft.com/office/drawing/2014/main" xmlns="" id="{699CC631-D84F-E098-C402-339DDB4E55F9}"/>
               </a:ext>
             </a:extLst>
           </p:cNvPr>
@@ -1931,7 +1931,7 @@
           <p:cNvPr id="30" name="Picture 29">
             <a:extLst>
               <a:ext uri="{FF2B5EF4-FFF2-40B4-BE49-F238E27FC236}">
-                <a16:creationId xmlns:a16="http://schemas.microsoft.com/office/drawing/2014/main" id="{F9C3B992-46BC-562E-59F9-2CDCDD52440C}"/>
+                <a16:creationId xmlns:a16="http://schemas.microsoft.com/office/drawing/2014/main" xmlns="" id="{F9C3B992-46BC-562E-59F9-2CDCDD52440C}"/>
               </a:ext>
             </a:extLst>
           </p:cNvPr>
@@ -1991,7 +1991,7 @@
           <p:cNvPr id="4" name="Shape 2">
             <a:extLst>
               <a:ext uri="{FF2B5EF4-FFF2-40B4-BE49-F238E27FC236}">
-                <a16:creationId xmlns:a16="http://schemas.microsoft.com/office/drawing/2014/main" id="{081EB42C-7403-8C44-5105-9393B8AA65E4}"/>
+                <a16:creationId xmlns:a16="http://schemas.microsoft.com/office/drawing/2014/main" xmlns="" id="{081EB42C-7403-8C44-5105-9393B8AA65E4}"/>
               </a:ext>
             </a:extLst>
           </p:cNvPr>
@@ -2022,7 +2022,7 @@
           <p:cNvPr id="5" name="Text 3">
             <a:extLst>
               <a:ext uri="{FF2B5EF4-FFF2-40B4-BE49-F238E27FC236}">
-                <a16:creationId xmlns:a16="http://schemas.microsoft.com/office/drawing/2014/main" id="{E69B80E3-F4FC-E0F4-8123-DAA496876E66}"/>
+                <a16:creationId xmlns:a16="http://schemas.microsoft.com/office/drawing/2014/main" xmlns="" id="{E69B80E3-F4FC-E0F4-8123-DAA496876E66}"/>
               </a:ext>
             </a:extLst>
           </p:cNvPr>
@@ -2067,7 +2067,7 @@
           <p:cNvPr id="6" name="Shape 4">
             <a:extLst>
               <a:ext uri="{FF2B5EF4-FFF2-40B4-BE49-F238E27FC236}">
-                <a16:creationId xmlns:a16="http://schemas.microsoft.com/office/drawing/2014/main" id="{CFC7EB49-3639-FF74-F162-53864F05A9EF}"/>
+                <a16:creationId xmlns:a16="http://schemas.microsoft.com/office/drawing/2014/main" xmlns="" id="{CFC7EB49-3639-FF74-F162-53864F05A9EF}"/>
               </a:ext>
             </a:extLst>
           </p:cNvPr>
@@ -2098,7 +2098,7 @@
           <p:cNvPr id="8" name="Text 6">
             <a:extLst>
               <a:ext uri="{FF2B5EF4-FFF2-40B4-BE49-F238E27FC236}">
-                <a16:creationId xmlns:a16="http://schemas.microsoft.com/office/drawing/2014/main" id="{2E4B7429-F6EB-0B10-8A7B-5509B557F297}"/>
+                <a16:creationId xmlns:a16="http://schemas.microsoft.com/office/drawing/2014/main" xmlns="" id="{2E4B7429-F6EB-0B10-8A7B-5509B557F297}"/>
               </a:ext>
             </a:extLst>
           </p:cNvPr>
@@ -2140,7 +2140,7 @@
           <p:cNvPr id="9" name="Text 7">
             <a:extLst>
               <a:ext uri="{FF2B5EF4-FFF2-40B4-BE49-F238E27FC236}">
-                <a16:creationId xmlns:a16="http://schemas.microsoft.com/office/drawing/2014/main" id="{53802D0E-EFD4-300F-3091-CBB1B597AC03}"/>
+                <a16:creationId xmlns:a16="http://schemas.microsoft.com/office/drawing/2014/main" xmlns="" id="{53802D0E-EFD4-300F-3091-CBB1B597AC03}"/>
               </a:ext>
             </a:extLst>
           </p:cNvPr>
@@ -2182,7 +2182,7 @@
           <p:cNvPr id="10" name="Text 8">
             <a:extLst>
               <a:ext uri="{FF2B5EF4-FFF2-40B4-BE49-F238E27FC236}">
-                <a16:creationId xmlns:a16="http://schemas.microsoft.com/office/drawing/2014/main" id="{1DB08042-FFBC-2202-971B-21A6DD0401E5}"/>
+                <a16:creationId xmlns:a16="http://schemas.microsoft.com/office/drawing/2014/main" xmlns="" id="{1DB08042-FFBC-2202-971B-21A6DD0401E5}"/>
               </a:ext>
             </a:extLst>
           </p:cNvPr>
@@ -6472,7 +6472,7 @@
           <p:cNvPr id="48" name="Shape 14">
             <a:extLst>
               <a:ext uri="{FF2B5EF4-FFF2-40B4-BE49-F238E27FC236}">
-                <a16:creationId xmlns:a16="http://schemas.microsoft.com/office/drawing/2014/main" id="{45D457CD-DFEE-363E-4E33-AD417E43FA81}"/>
+                <a16:creationId xmlns:a16="http://schemas.microsoft.com/office/drawing/2014/main" xmlns="" id="{45D457CD-DFEE-363E-4E33-AD417E43FA81}"/>
               </a:ext>
             </a:extLst>
           </p:cNvPr>
@@ -6507,7 +6507,7 @@
           <p:cNvPr id="50" name="TextBox 49">
             <a:extLst>
               <a:ext uri="{FF2B5EF4-FFF2-40B4-BE49-F238E27FC236}">
-                <a16:creationId xmlns:a16="http://schemas.microsoft.com/office/drawing/2014/main" id="{5D858DAB-CD0D-AAD0-789A-D4B5BE908DA3}"/>
+                <a16:creationId xmlns:a16="http://schemas.microsoft.com/office/drawing/2014/main" xmlns="" id="{5D858DAB-CD0D-AAD0-789A-D4B5BE908DA3}"/>
               </a:ext>
             </a:extLst>
           </p:cNvPr>
@@ -6547,7 +6547,7 @@
           <p:cNvPr id="51" name="Image 0" descr="preencoded.png">
             <a:extLst>
               <a:ext uri="{FF2B5EF4-FFF2-40B4-BE49-F238E27FC236}">
-                <a16:creationId xmlns:a16="http://schemas.microsoft.com/office/drawing/2014/main" id="{08445E86-6AD4-AA7D-1A6D-9705D3705983}"/>
+                <a16:creationId xmlns:a16="http://schemas.microsoft.com/office/drawing/2014/main" xmlns="" id="{08445E86-6AD4-AA7D-1A6D-9705D3705983}"/>
               </a:ext>
             </a:extLst>
           </p:cNvPr>
@@ -6585,7 +6585,7 @@
           <p:cNvPr id="54" name="TextBox 53">
             <a:extLst>
               <a:ext uri="{FF2B5EF4-FFF2-40B4-BE49-F238E27FC236}">
-                <a16:creationId xmlns:a16="http://schemas.microsoft.com/office/drawing/2014/main" id="{063B844F-8708-12FF-B2D5-57AE20B79092}"/>
+                <a16:creationId xmlns:a16="http://schemas.microsoft.com/office/drawing/2014/main" xmlns="" id="{063B844F-8708-12FF-B2D5-57AE20B79092}"/>
               </a:ext>
             </a:extLst>
           </p:cNvPr>
@@ -6625,7 +6625,7 @@
           <p:cNvPr id="56" name="Picture 55">
             <a:extLst>
               <a:ext uri="{FF2B5EF4-FFF2-40B4-BE49-F238E27FC236}">
-                <a16:creationId xmlns:a16="http://schemas.microsoft.com/office/drawing/2014/main" id="{8679AA37-90D8-6919-7C0F-7C0FB310C94C}"/>
+                <a16:creationId xmlns:a16="http://schemas.microsoft.com/office/drawing/2014/main" xmlns="" id="{8679AA37-90D8-6919-7C0F-7C0FB310C94C}"/>
               </a:ext>
             </a:extLst>
           </p:cNvPr>
@@ -7256,12 +7256,28 @@
               <a:buNone/>
             </a:pPr>
             <a:r>
+              <a:rPr lang="en-US" sz="1050" b="1" dirty="0" err="1" smtClean="0">
+                <a:solidFill>
+                  <a:srgbClr val="002060"/>
+                </a:solidFill>
+              </a:rPr>
+              <a:t>AdamW</a:t>
+            </a:r>
+            <a:r>
+              <a:rPr lang="en-US" sz="1050" b="1" smtClean="0">
+                <a:solidFill>
+                  <a:srgbClr val="002060"/>
+                </a:solidFill>
+              </a:rPr>
+              <a:t> (momentum </a:t>
+            </a:r>
+            <a:r>
               <a:rPr lang="en-US" sz="1050" b="1" dirty="0">
                 <a:solidFill>
                   <a:srgbClr val="002060"/>
                 </a:solidFill>
               </a:rPr>
-              <a:t>SGD  (momentum = 0.937)</a:t>
+              <a:t>= 0.937)</a:t>
             </a:r>
             <a:endParaRPr lang="en-US" sz="1050" dirty="0">
               <a:solidFill>
@@ -9016,7 +9032,7 @@
           <p:cNvPr id="4" name="Shape 0">
             <a:extLst>
               <a:ext uri="{FF2B5EF4-FFF2-40B4-BE49-F238E27FC236}">
-                <a16:creationId xmlns:a16="http://schemas.microsoft.com/office/drawing/2014/main" id="{A9B983E9-266B-EB54-46CA-44F44B186A0B}"/>
+                <a16:creationId xmlns:a16="http://schemas.microsoft.com/office/drawing/2014/main" xmlns="" id="{A9B983E9-266B-EB54-46CA-44F44B186A0B}"/>
               </a:ext>
             </a:extLst>
           </p:cNvPr>
@@ -9047,7 +9063,7 @@
           <p:cNvPr id="6" name="Shape 1">
             <a:extLst>
               <a:ext uri="{FF2B5EF4-FFF2-40B4-BE49-F238E27FC236}">
-                <a16:creationId xmlns:a16="http://schemas.microsoft.com/office/drawing/2014/main" id="{7CBB8927-4B2A-0387-315A-F32CB3D45CBB}"/>
+                <a16:creationId xmlns:a16="http://schemas.microsoft.com/office/drawing/2014/main" xmlns="" id="{7CBB8927-4B2A-0387-315A-F32CB3D45CBB}"/>
               </a:ext>
             </a:extLst>
           </p:cNvPr>
@@ -9078,7 +9094,7 @@
           <p:cNvPr id="8" name="Text 2">
             <a:extLst>
               <a:ext uri="{FF2B5EF4-FFF2-40B4-BE49-F238E27FC236}">
-                <a16:creationId xmlns:a16="http://schemas.microsoft.com/office/drawing/2014/main" id="{3C155AA2-0A7B-E685-B78C-A1A93A3E9188}"/>
+                <a16:creationId xmlns:a16="http://schemas.microsoft.com/office/drawing/2014/main" xmlns="" id="{3C155AA2-0A7B-E685-B78C-A1A93A3E9188}"/>
               </a:ext>
             </a:extLst>
           </p:cNvPr>
@@ -9117,7 +9133,7 @@
           <p:cNvPr id="12" name="Text 4">
             <a:extLst>
               <a:ext uri="{FF2B5EF4-FFF2-40B4-BE49-F238E27FC236}">
-                <a16:creationId xmlns:a16="http://schemas.microsoft.com/office/drawing/2014/main" id="{E09060B9-7ABF-1B5E-C84D-77B799AB0FF2}"/>
+                <a16:creationId xmlns:a16="http://schemas.microsoft.com/office/drawing/2014/main" xmlns="" id="{E09060B9-7ABF-1B5E-C84D-77B799AB0FF2}"/>
               </a:ext>
             </a:extLst>
           </p:cNvPr>
@@ -9151,7 +9167,7 @@
           <p:cNvPr id="14" name="Shape 5">
             <a:extLst>
               <a:ext uri="{FF2B5EF4-FFF2-40B4-BE49-F238E27FC236}">
-                <a16:creationId xmlns:a16="http://schemas.microsoft.com/office/drawing/2014/main" id="{D27125F7-0419-FC86-72D2-C85A972EA7BF}"/>
+                <a16:creationId xmlns:a16="http://schemas.microsoft.com/office/drawing/2014/main" xmlns="" id="{D27125F7-0419-FC86-72D2-C85A972EA7BF}"/>
               </a:ext>
             </a:extLst>
           </p:cNvPr>
@@ -9189,7 +9205,7 @@
           <p:cNvPr id="16" name="Shape 6">
             <a:extLst>
               <a:ext uri="{FF2B5EF4-FFF2-40B4-BE49-F238E27FC236}">
-                <a16:creationId xmlns:a16="http://schemas.microsoft.com/office/drawing/2014/main" id="{D7D554AB-FECA-3EBA-BC1E-E52F6B89EBA8}"/>
+                <a16:creationId xmlns:a16="http://schemas.microsoft.com/office/drawing/2014/main" xmlns="" id="{D7D554AB-FECA-3EBA-BC1E-E52F6B89EBA8}"/>
               </a:ext>
             </a:extLst>
           </p:cNvPr>
@@ -9220,7 +9236,7 @@
           <p:cNvPr id="18" name="Text 7">
             <a:extLst>
               <a:ext uri="{FF2B5EF4-FFF2-40B4-BE49-F238E27FC236}">
-                <a16:creationId xmlns:a16="http://schemas.microsoft.com/office/drawing/2014/main" id="{CC1409BF-FF70-4634-FB58-223431E16051}"/>
+                <a16:creationId xmlns:a16="http://schemas.microsoft.com/office/drawing/2014/main" xmlns="" id="{CC1409BF-FF70-4634-FB58-223431E16051}"/>
               </a:ext>
             </a:extLst>
           </p:cNvPr>
@@ -9266,7 +9282,7 @@
           <p:cNvPr id="20" name="Text 8">
             <a:extLst>
               <a:ext uri="{FF2B5EF4-FFF2-40B4-BE49-F238E27FC236}">
-                <a16:creationId xmlns:a16="http://schemas.microsoft.com/office/drawing/2014/main" id="{8614140E-E9C4-E693-49D2-31A1F730D3C1}"/>
+                <a16:creationId xmlns:a16="http://schemas.microsoft.com/office/drawing/2014/main" xmlns="" id="{8614140E-E9C4-E693-49D2-31A1F730D3C1}"/>
               </a:ext>
             </a:extLst>
           </p:cNvPr>
@@ -9307,7 +9323,7 @@
           <p:cNvPr id="22" name="Text 9">
             <a:extLst>
               <a:ext uri="{FF2B5EF4-FFF2-40B4-BE49-F238E27FC236}">
-                <a16:creationId xmlns:a16="http://schemas.microsoft.com/office/drawing/2014/main" id="{23DB82E1-B8A9-3E9B-4386-6438C324BB7D}"/>
+                <a16:creationId xmlns:a16="http://schemas.microsoft.com/office/drawing/2014/main" xmlns="" id="{23DB82E1-B8A9-3E9B-4386-6438C324BB7D}"/>
               </a:ext>
             </a:extLst>
           </p:cNvPr>
@@ -9353,7 +9369,7 @@
           <p:cNvPr id="24" name="Shape 10">
             <a:extLst>
               <a:ext uri="{FF2B5EF4-FFF2-40B4-BE49-F238E27FC236}">
-                <a16:creationId xmlns:a16="http://schemas.microsoft.com/office/drawing/2014/main" id="{397642C4-F4B8-0F11-6993-EF73BDFF22C9}"/>
+                <a16:creationId xmlns:a16="http://schemas.microsoft.com/office/drawing/2014/main" xmlns="" id="{397642C4-F4B8-0F11-6993-EF73BDFF22C9}"/>
               </a:ext>
             </a:extLst>
           </p:cNvPr>
@@ -9391,7 +9407,7 @@
           <p:cNvPr id="26" name="Shape 11">
             <a:extLst>
               <a:ext uri="{FF2B5EF4-FFF2-40B4-BE49-F238E27FC236}">
-                <a16:creationId xmlns:a16="http://schemas.microsoft.com/office/drawing/2014/main" id="{4BB7A93B-5A96-4574-E757-56FED3382705}"/>
+                <a16:creationId xmlns:a16="http://schemas.microsoft.com/office/drawing/2014/main" xmlns="" id="{4BB7A93B-5A96-4574-E757-56FED3382705}"/>
               </a:ext>
             </a:extLst>
           </p:cNvPr>
@@ -9426,7 +9442,7 @@
           <p:cNvPr id="28" name="Text 12">
             <a:extLst>
               <a:ext uri="{FF2B5EF4-FFF2-40B4-BE49-F238E27FC236}">
-                <a16:creationId xmlns:a16="http://schemas.microsoft.com/office/drawing/2014/main" id="{71F04ECE-8D9A-6D09-1A85-F7AC7BD14F40}"/>
+                <a16:creationId xmlns:a16="http://schemas.microsoft.com/office/drawing/2014/main" xmlns="" id="{71F04ECE-8D9A-6D09-1A85-F7AC7BD14F40}"/>
               </a:ext>
             </a:extLst>
           </p:cNvPr>
@@ -9476,7 +9492,7 @@
           <p:cNvPr id="30" name="Text 13">
             <a:extLst>
               <a:ext uri="{FF2B5EF4-FFF2-40B4-BE49-F238E27FC236}">
-                <a16:creationId xmlns:a16="http://schemas.microsoft.com/office/drawing/2014/main" id="{4E586FD9-EA2A-D2F9-04E5-E62E7F931A26}"/>
+                <a16:creationId xmlns:a16="http://schemas.microsoft.com/office/drawing/2014/main" xmlns="" id="{4E586FD9-EA2A-D2F9-04E5-E62E7F931A26}"/>
               </a:ext>
             </a:extLst>
           </p:cNvPr>
@@ -9519,7 +9535,7 @@
           <p:cNvPr id="32" name="Text 14">
             <a:extLst>
               <a:ext uri="{FF2B5EF4-FFF2-40B4-BE49-F238E27FC236}">
-                <a16:creationId xmlns:a16="http://schemas.microsoft.com/office/drawing/2014/main" id="{1F92A777-AA14-0B79-D43D-FA5B1D0FC955}"/>
+                <a16:creationId xmlns:a16="http://schemas.microsoft.com/office/drawing/2014/main" xmlns="" id="{1F92A777-AA14-0B79-D43D-FA5B1D0FC955}"/>
               </a:ext>
             </a:extLst>
           </p:cNvPr>
@@ -9569,7 +9585,7 @@
           <p:cNvPr id="34" name="Shape 15">
             <a:extLst>
               <a:ext uri="{FF2B5EF4-FFF2-40B4-BE49-F238E27FC236}">
-                <a16:creationId xmlns:a16="http://schemas.microsoft.com/office/drawing/2014/main" id="{A162135A-4153-EB67-5B86-46F84B323566}"/>
+                <a16:creationId xmlns:a16="http://schemas.microsoft.com/office/drawing/2014/main" xmlns="" id="{A162135A-4153-EB67-5B86-46F84B323566}"/>
               </a:ext>
             </a:extLst>
           </p:cNvPr>
@@ -9607,7 +9623,7 @@
           <p:cNvPr id="36" name="Shape 16">
             <a:extLst>
               <a:ext uri="{FF2B5EF4-FFF2-40B4-BE49-F238E27FC236}">
-                <a16:creationId xmlns:a16="http://schemas.microsoft.com/office/drawing/2014/main" id="{7EDFE522-5306-9424-7551-D4727D9DDAA2}"/>
+                <a16:creationId xmlns:a16="http://schemas.microsoft.com/office/drawing/2014/main" xmlns="" id="{7EDFE522-5306-9424-7551-D4727D9DDAA2}"/>
               </a:ext>
             </a:extLst>
           </p:cNvPr>
@@ -9638,7 +9654,7 @@
           <p:cNvPr id="38" name="Text 17">
             <a:extLst>
               <a:ext uri="{FF2B5EF4-FFF2-40B4-BE49-F238E27FC236}">
-                <a16:creationId xmlns:a16="http://schemas.microsoft.com/office/drawing/2014/main" id="{81A7B3A1-A2B9-AE1B-5A95-D9A47EFDA002}"/>
+                <a16:creationId xmlns:a16="http://schemas.microsoft.com/office/drawing/2014/main" xmlns="" id="{81A7B3A1-A2B9-AE1B-5A95-D9A47EFDA002}"/>
               </a:ext>
             </a:extLst>
           </p:cNvPr>
@@ -9680,7 +9696,7 @@
           <p:cNvPr id="40" name="Text 18">
             <a:extLst>
               <a:ext uri="{FF2B5EF4-FFF2-40B4-BE49-F238E27FC236}">
-                <a16:creationId xmlns:a16="http://schemas.microsoft.com/office/drawing/2014/main" id="{BCE65E42-74A1-A067-5148-48712EDE627B}"/>
+                <a16:creationId xmlns:a16="http://schemas.microsoft.com/office/drawing/2014/main" xmlns="" id="{BCE65E42-74A1-A067-5148-48712EDE627B}"/>
               </a:ext>
             </a:extLst>
           </p:cNvPr>
@@ -9721,7 +9737,7 @@
           <p:cNvPr id="42" name="Text 19">
             <a:extLst>
               <a:ext uri="{FF2B5EF4-FFF2-40B4-BE49-F238E27FC236}">
-                <a16:creationId xmlns:a16="http://schemas.microsoft.com/office/drawing/2014/main" id="{9F30EFB7-2B85-D92B-9F5C-E743943AA52D}"/>
+                <a16:creationId xmlns:a16="http://schemas.microsoft.com/office/drawing/2014/main" xmlns="" id="{9F30EFB7-2B85-D92B-9F5C-E743943AA52D}"/>
               </a:ext>
             </a:extLst>
           </p:cNvPr>
@@ -9767,7 +9783,7 @@
           <p:cNvPr id="44" name="Text 23">
             <a:extLst>
               <a:ext uri="{FF2B5EF4-FFF2-40B4-BE49-F238E27FC236}">
-                <a16:creationId xmlns:a16="http://schemas.microsoft.com/office/drawing/2014/main" id="{430EE856-E098-590D-88D6-DDDCA8556376}"/>
+                <a16:creationId xmlns:a16="http://schemas.microsoft.com/office/drawing/2014/main" xmlns="" id="{430EE856-E098-590D-88D6-DDDCA8556376}"/>
               </a:ext>
             </a:extLst>
           </p:cNvPr>
@@ -9807,7 +9823,7 @@
           <p:cNvPr id="46" name="Text 24">
             <a:extLst>
               <a:ext uri="{FF2B5EF4-FFF2-40B4-BE49-F238E27FC236}">
-                <a16:creationId xmlns:a16="http://schemas.microsoft.com/office/drawing/2014/main" id="{3B54CC46-439A-2AF6-2B73-2A14D57DB847}"/>
+                <a16:creationId xmlns:a16="http://schemas.microsoft.com/office/drawing/2014/main" xmlns="" id="{3B54CC46-439A-2AF6-2B73-2A14D57DB847}"/>
               </a:ext>
             </a:extLst>
           </p:cNvPr>
@@ -9849,7 +9865,7 @@
           <p:cNvPr id="2" name="Shape 5">
             <a:extLst>
               <a:ext uri="{FF2B5EF4-FFF2-40B4-BE49-F238E27FC236}">
-                <a16:creationId xmlns:a16="http://schemas.microsoft.com/office/drawing/2014/main" id="{AD60ECD7-D4DB-DD67-1EA6-14113B6BE56C}"/>
+                <a16:creationId xmlns:a16="http://schemas.microsoft.com/office/drawing/2014/main" xmlns="" id="{AD60ECD7-D4DB-DD67-1EA6-14113B6BE56C}"/>
               </a:ext>
             </a:extLst>
           </p:cNvPr>
@@ -9887,7 +9903,7 @@
           <p:cNvPr id="3" name="Shape 6">
             <a:extLst>
               <a:ext uri="{FF2B5EF4-FFF2-40B4-BE49-F238E27FC236}">
-                <a16:creationId xmlns:a16="http://schemas.microsoft.com/office/drawing/2014/main" id="{A0989504-9BED-DABB-8862-FCD5758716C2}"/>
+                <a16:creationId xmlns:a16="http://schemas.microsoft.com/office/drawing/2014/main" xmlns="" id="{A0989504-9BED-DABB-8862-FCD5758716C2}"/>
               </a:ext>
             </a:extLst>
           </p:cNvPr>
@@ -9918,7 +9934,7 @@
           <p:cNvPr id="5" name="Text 7">
             <a:extLst>
               <a:ext uri="{FF2B5EF4-FFF2-40B4-BE49-F238E27FC236}">
-                <a16:creationId xmlns:a16="http://schemas.microsoft.com/office/drawing/2014/main" id="{D4E9740B-47C4-0051-E55F-35557016CAB7}"/>
+                <a16:creationId xmlns:a16="http://schemas.microsoft.com/office/drawing/2014/main" xmlns="" id="{D4E9740B-47C4-0051-E55F-35557016CAB7}"/>
               </a:ext>
             </a:extLst>
           </p:cNvPr>
@@ -9964,7 +9980,7 @@
           <p:cNvPr id="7" name="Text 8">
             <a:extLst>
               <a:ext uri="{FF2B5EF4-FFF2-40B4-BE49-F238E27FC236}">
-                <a16:creationId xmlns:a16="http://schemas.microsoft.com/office/drawing/2014/main" id="{FAEF54B6-9549-BA02-A2FD-6F7CE10E949E}"/>
+                <a16:creationId xmlns:a16="http://schemas.microsoft.com/office/drawing/2014/main" xmlns="" id="{FAEF54B6-9549-BA02-A2FD-6F7CE10E949E}"/>
               </a:ext>
             </a:extLst>
           </p:cNvPr>
@@ -10005,7 +10021,7 @@
           <p:cNvPr id="9" name="Text 9">
             <a:extLst>
               <a:ext uri="{FF2B5EF4-FFF2-40B4-BE49-F238E27FC236}">
-                <a16:creationId xmlns:a16="http://schemas.microsoft.com/office/drawing/2014/main" id="{03DEB4E6-C6D2-98DD-CF87-4F59DA47C4D1}"/>
+                <a16:creationId xmlns:a16="http://schemas.microsoft.com/office/drawing/2014/main" xmlns="" id="{03DEB4E6-C6D2-98DD-CF87-4F59DA47C4D1}"/>
               </a:ext>
             </a:extLst>
           </p:cNvPr>
@@ -10051,7 +10067,7 @@
           <p:cNvPr id="10" name="Shape 10">
             <a:extLst>
               <a:ext uri="{FF2B5EF4-FFF2-40B4-BE49-F238E27FC236}">
-                <a16:creationId xmlns:a16="http://schemas.microsoft.com/office/drawing/2014/main" id="{B847EB4A-F803-657B-808D-853D4438AFD8}"/>
+                <a16:creationId xmlns:a16="http://schemas.microsoft.com/office/drawing/2014/main" xmlns="" id="{B847EB4A-F803-657B-808D-853D4438AFD8}"/>
               </a:ext>
             </a:extLst>
           </p:cNvPr>
@@ -10089,7 +10105,7 @@
           <p:cNvPr id="11" name="Shape 11">
             <a:extLst>
               <a:ext uri="{FF2B5EF4-FFF2-40B4-BE49-F238E27FC236}">
-                <a16:creationId xmlns:a16="http://schemas.microsoft.com/office/drawing/2014/main" id="{511DE68E-2A28-BC5C-C813-2A703CB567F4}"/>
+                <a16:creationId xmlns:a16="http://schemas.microsoft.com/office/drawing/2014/main" xmlns="" id="{511DE68E-2A28-BC5C-C813-2A703CB567F4}"/>
               </a:ext>
             </a:extLst>
           </p:cNvPr>
@@ -10124,7 +10140,7 @@
           <p:cNvPr id="13" name="Text 12">
             <a:extLst>
               <a:ext uri="{FF2B5EF4-FFF2-40B4-BE49-F238E27FC236}">
-                <a16:creationId xmlns:a16="http://schemas.microsoft.com/office/drawing/2014/main" id="{62C16DFE-5F1B-CDE0-D6F9-89C3EA8B8BC1}"/>
+                <a16:creationId xmlns:a16="http://schemas.microsoft.com/office/drawing/2014/main" xmlns="" id="{62C16DFE-5F1B-CDE0-D6F9-89C3EA8B8BC1}"/>
               </a:ext>
             </a:extLst>
           </p:cNvPr>
@@ -10174,7 +10190,7 @@
           <p:cNvPr id="15" name="Text 13">
             <a:extLst>
               <a:ext uri="{FF2B5EF4-FFF2-40B4-BE49-F238E27FC236}">
-                <a16:creationId xmlns:a16="http://schemas.microsoft.com/office/drawing/2014/main" id="{B460AC3A-8F82-995D-F1E4-43A7BEE289A7}"/>
+                <a16:creationId xmlns:a16="http://schemas.microsoft.com/office/drawing/2014/main" xmlns="" id="{B460AC3A-8F82-995D-F1E4-43A7BEE289A7}"/>
               </a:ext>
             </a:extLst>
           </p:cNvPr>
@@ -10217,7 +10233,7 @@
           <p:cNvPr id="17" name="Text 14">
             <a:extLst>
               <a:ext uri="{FF2B5EF4-FFF2-40B4-BE49-F238E27FC236}">
-                <a16:creationId xmlns:a16="http://schemas.microsoft.com/office/drawing/2014/main" id="{BFB007C1-2B8A-FD86-0D74-160370E732CA}"/>
+                <a16:creationId xmlns:a16="http://schemas.microsoft.com/office/drawing/2014/main" xmlns="" id="{BFB007C1-2B8A-FD86-0D74-160370E732CA}"/>
               </a:ext>
             </a:extLst>
           </p:cNvPr>
@@ -10267,7 +10283,7 @@
           <p:cNvPr id="19" name="Shape 15">
             <a:extLst>
               <a:ext uri="{FF2B5EF4-FFF2-40B4-BE49-F238E27FC236}">
-                <a16:creationId xmlns:a16="http://schemas.microsoft.com/office/drawing/2014/main" id="{34508471-F64D-874E-41BE-6E5F2AE2838D}"/>
+                <a16:creationId xmlns:a16="http://schemas.microsoft.com/office/drawing/2014/main" xmlns="" id="{34508471-F64D-874E-41BE-6E5F2AE2838D}"/>
               </a:ext>
             </a:extLst>
           </p:cNvPr>
@@ -10305,7 +10321,7 @@
           <p:cNvPr id="21" name="Shape 16">
             <a:extLst>
               <a:ext uri="{FF2B5EF4-FFF2-40B4-BE49-F238E27FC236}">
-                <a16:creationId xmlns:a16="http://schemas.microsoft.com/office/drawing/2014/main" id="{5EEB45B3-63F5-1F74-A649-AC484F743A87}"/>
+                <a16:creationId xmlns:a16="http://schemas.microsoft.com/office/drawing/2014/main" xmlns="" id="{5EEB45B3-63F5-1F74-A649-AC484F743A87}"/>
               </a:ext>
             </a:extLst>
           </p:cNvPr>
@@ -10336,7 +10352,7 @@
           <p:cNvPr id="23" name="Text 17">
             <a:extLst>
               <a:ext uri="{FF2B5EF4-FFF2-40B4-BE49-F238E27FC236}">
-                <a16:creationId xmlns:a16="http://schemas.microsoft.com/office/drawing/2014/main" id="{8AB67B1D-9644-3F64-CDEA-31AE7992317F}"/>
+                <a16:creationId xmlns:a16="http://schemas.microsoft.com/office/drawing/2014/main" xmlns="" id="{8AB67B1D-9644-3F64-CDEA-31AE7992317F}"/>
               </a:ext>
             </a:extLst>
           </p:cNvPr>
@@ -10378,7 +10394,7 @@
           <p:cNvPr id="25" name="Text 18">
             <a:extLst>
               <a:ext uri="{FF2B5EF4-FFF2-40B4-BE49-F238E27FC236}">
-                <a16:creationId xmlns:a16="http://schemas.microsoft.com/office/drawing/2014/main" id="{317EAB13-E8FD-8480-75BA-3F7AD126D6F5}"/>
+                <a16:creationId xmlns:a16="http://schemas.microsoft.com/office/drawing/2014/main" xmlns="" id="{317EAB13-E8FD-8480-75BA-3F7AD126D6F5}"/>
               </a:ext>
             </a:extLst>
           </p:cNvPr>
@@ -10419,7 +10435,7 @@
           <p:cNvPr id="27" name="Text 19">
             <a:extLst>
               <a:ext uri="{FF2B5EF4-FFF2-40B4-BE49-F238E27FC236}">
-                <a16:creationId xmlns:a16="http://schemas.microsoft.com/office/drawing/2014/main" id="{8E29360E-3165-BF7A-A929-802DFA45E6A2}"/>
+                <a16:creationId xmlns:a16="http://schemas.microsoft.com/office/drawing/2014/main" xmlns="" id="{8E29360E-3165-BF7A-A929-802DFA45E6A2}"/>
               </a:ext>
             </a:extLst>
           </p:cNvPr>
@@ -10465,7 +10481,7 @@
           <p:cNvPr id="29" name="Text 23">
             <a:extLst>
               <a:ext uri="{FF2B5EF4-FFF2-40B4-BE49-F238E27FC236}">
-                <a16:creationId xmlns:a16="http://schemas.microsoft.com/office/drawing/2014/main" id="{D8BEC7E4-45FE-0C64-2D92-5F038A51E4FB}"/>
+                <a16:creationId xmlns:a16="http://schemas.microsoft.com/office/drawing/2014/main" xmlns="" id="{D8BEC7E4-45FE-0C64-2D92-5F038A51E4FB}"/>
               </a:ext>
             </a:extLst>
           </p:cNvPr>
@@ -10505,7 +10521,7 @@
           <p:cNvPr id="31" name="Text 24">
             <a:extLst>
               <a:ext uri="{FF2B5EF4-FFF2-40B4-BE49-F238E27FC236}">
-                <a16:creationId xmlns:a16="http://schemas.microsoft.com/office/drawing/2014/main" id="{B1414C0C-344E-1CA4-BA30-FBEACDB72686}"/>
+                <a16:creationId xmlns:a16="http://schemas.microsoft.com/office/drawing/2014/main" xmlns="" id="{B1414C0C-344E-1CA4-BA30-FBEACDB72686}"/>
               </a:ext>
             </a:extLst>
           </p:cNvPr>
@@ -10547,7 +10563,7 @@
           <p:cNvPr id="33" name="TextBox 32">
             <a:extLst>
               <a:ext uri="{FF2B5EF4-FFF2-40B4-BE49-F238E27FC236}">
-                <a16:creationId xmlns:a16="http://schemas.microsoft.com/office/drawing/2014/main" id="{E1B6D471-F978-75D4-C772-598382F710AF}"/>
+                <a16:creationId xmlns:a16="http://schemas.microsoft.com/office/drawing/2014/main" xmlns="" id="{E1B6D471-F978-75D4-C772-598382F710AF}"/>
               </a:ext>
             </a:extLst>
           </p:cNvPr>
@@ -10591,7 +10607,7 @@
           <p:cNvPr id="35" name="TextBox 34">
             <a:extLst>
               <a:ext uri="{FF2B5EF4-FFF2-40B4-BE49-F238E27FC236}">
-                <a16:creationId xmlns:a16="http://schemas.microsoft.com/office/drawing/2014/main" id="{46772D9D-8E93-284F-2ECD-F152C08CCCF8}"/>
+                <a16:creationId xmlns:a16="http://schemas.microsoft.com/office/drawing/2014/main" xmlns="" id="{46772D9D-8E93-284F-2ECD-F152C08CCCF8}"/>
               </a:ext>
             </a:extLst>
           </p:cNvPr>
@@ -10660,7 +10676,7 @@
           <p:cNvPr id="2" name="Shape 0">
             <a:extLst>
               <a:ext uri="{FF2B5EF4-FFF2-40B4-BE49-F238E27FC236}">
-                <a16:creationId xmlns:a16="http://schemas.microsoft.com/office/drawing/2014/main" id="{E04063A6-8D70-5AF8-5A26-F1274C848864}"/>
+                <a16:creationId xmlns:a16="http://schemas.microsoft.com/office/drawing/2014/main" xmlns="" id="{E04063A6-8D70-5AF8-5A26-F1274C848864}"/>
               </a:ext>
             </a:extLst>
           </p:cNvPr>
@@ -10691,7 +10707,7 @@
           <p:cNvPr id="3" name="Shape 1">
             <a:extLst>
               <a:ext uri="{FF2B5EF4-FFF2-40B4-BE49-F238E27FC236}">
-                <a16:creationId xmlns:a16="http://schemas.microsoft.com/office/drawing/2014/main" id="{C9A9EE38-9834-6B91-8063-9079A5954851}"/>
+                <a16:creationId xmlns:a16="http://schemas.microsoft.com/office/drawing/2014/main" xmlns="" id="{C9A9EE38-9834-6B91-8063-9079A5954851}"/>
               </a:ext>
             </a:extLst>
           </p:cNvPr>
@@ -10722,7 +10738,7 @@
           <p:cNvPr id="4" name="Text 2">
             <a:extLst>
               <a:ext uri="{FF2B5EF4-FFF2-40B4-BE49-F238E27FC236}">
-                <a16:creationId xmlns:a16="http://schemas.microsoft.com/office/drawing/2014/main" id="{C2AC71D3-A93B-44B9-4C07-22BC28D4F235}"/>
+                <a16:creationId xmlns:a16="http://schemas.microsoft.com/office/drawing/2014/main" xmlns="" id="{C2AC71D3-A93B-44B9-4C07-22BC28D4F235}"/>
               </a:ext>
             </a:extLst>
           </p:cNvPr>
@@ -10767,7 +10783,7 @@
           <p:cNvPr id="6" name="Text 5">
             <a:extLst>
               <a:ext uri="{FF2B5EF4-FFF2-40B4-BE49-F238E27FC236}">
-                <a16:creationId xmlns:a16="http://schemas.microsoft.com/office/drawing/2014/main" id="{2787C306-8987-E713-69B8-959F7C434B52}"/>
+                <a16:creationId xmlns:a16="http://schemas.microsoft.com/office/drawing/2014/main" xmlns="" id="{2787C306-8987-E713-69B8-959F7C434B52}"/>
               </a:ext>
             </a:extLst>
           </p:cNvPr>
@@ -10809,7 +10825,7 @@
           <p:cNvPr id="8" name="Text 34">
             <a:extLst>
               <a:ext uri="{FF2B5EF4-FFF2-40B4-BE49-F238E27FC236}">
-                <a16:creationId xmlns:a16="http://schemas.microsoft.com/office/drawing/2014/main" id="{1F3E2AC9-99F2-9C46-C2E4-E76E8AE4E06B}"/>
+                <a16:creationId xmlns:a16="http://schemas.microsoft.com/office/drawing/2014/main" xmlns="" id="{1F3E2AC9-99F2-9C46-C2E4-E76E8AE4E06B}"/>
               </a:ext>
             </a:extLst>
           </p:cNvPr>
@@ -10851,7 +10867,7 @@
           <p:cNvPr id="10" name="Picture 9">
             <a:extLst>
               <a:ext uri="{FF2B5EF4-FFF2-40B4-BE49-F238E27FC236}">
-                <a16:creationId xmlns:a16="http://schemas.microsoft.com/office/drawing/2014/main" id="{A3755DDE-D646-8E4F-2DE7-4DB81715C688}"/>
+                <a16:creationId xmlns:a16="http://schemas.microsoft.com/office/drawing/2014/main" xmlns="" id="{A3755DDE-D646-8E4F-2DE7-4DB81715C688}"/>
               </a:ext>
             </a:extLst>
           </p:cNvPr>
@@ -10881,7 +10897,7 @@
           <p:cNvPr id="12" name="Text 31">
             <a:extLst>
               <a:ext uri="{FF2B5EF4-FFF2-40B4-BE49-F238E27FC236}">
-                <a16:creationId xmlns:a16="http://schemas.microsoft.com/office/drawing/2014/main" id="{9167F0D6-7267-D821-C4F3-0C3FF22F79B5}"/>
+                <a16:creationId xmlns:a16="http://schemas.microsoft.com/office/drawing/2014/main" xmlns="" id="{9167F0D6-7267-D821-C4F3-0C3FF22F79B5}"/>
               </a:ext>
             </a:extLst>
           </p:cNvPr>
@@ -10926,7 +10942,7 @@
           <p:cNvPr id="14" name="Picture 13">
             <a:extLst>
               <a:ext uri="{FF2B5EF4-FFF2-40B4-BE49-F238E27FC236}">
-                <a16:creationId xmlns:a16="http://schemas.microsoft.com/office/drawing/2014/main" id="{FBD04FA8-C69A-10BF-0779-23E4163C9B4D}"/>
+                <a16:creationId xmlns:a16="http://schemas.microsoft.com/office/drawing/2014/main" xmlns="" id="{FBD04FA8-C69A-10BF-0779-23E4163C9B4D}"/>
               </a:ext>
             </a:extLst>
           </p:cNvPr>
@@ -10986,7 +11002,7 @@
           <p:cNvPr id="6" name="Shape 0">
             <a:extLst>
               <a:ext uri="{FF2B5EF4-FFF2-40B4-BE49-F238E27FC236}">
-                <a16:creationId xmlns:a16="http://schemas.microsoft.com/office/drawing/2014/main" id="{918BADE6-7699-2200-D9CE-776695C12927}"/>
+                <a16:creationId xmlns:a16="http://schemas.microsoft.com/office/drawing/2014/main" xmlns="" id="{918BADE6-7699-2200-D9CE-776695C12927}"/>
               </a:ext>
             </a:extLst>
           </p:cNvPr>
@@ -11017,7 +11033,7 @@
           <p:cNvPr id="7" name="Shape 1">
             <a:extLst>
               <a:ext uri="{FF2B5EF4-FFF2-40B4-BE49-F238E27FC236}">
-                <a16:creationId xmlns:a16="http://schemas.microsoft.com/office/drawing/2014/main" id="{4C207137-B9B5-FC77-5DD7-F6F76C67814D}"/>
+                <a16:creationId xmlns:a16="http://schemas.microsoft.com/office/drawing/2014/main" xmlns="" id="{4C207137-B9B5-FC77-5DD7-F6F76C67814D}"/>
               </a:ext>
             </a:extLst>
           </p:cNvPr>
@@ -11048,7 +11064,7 @@
           <p:cNvPr id="8" name="Text 2">
             <a:extLst>
               <a:ext uri="{FF2B5EF4-FFF2-40B4-BE49-F238E27FC236}">
-                <a16:creationId xmlns:a16="http://schemas.microsoft.com/office/drawing/2014/main" id="{821B0063-DDD1-9DEE-AA84-EC7B2019B925}"/>
+                <a16:creationId xmlns:a16="http://schemas.microsoft.com/office/drawing/2014/main" xmlns="" id="{821B0063-DDD1-9DEE-AA84-EC7B2019B925}"/>
               </a:ext>
             </a:extLst>
           </p:cNvPr>
@@ -11093,7 +11109,7 @@
           <p:cNvPr id="10" name="Text 4">
             <a:extLst>
               <a:ext uri="{FF2B5EF4-FFF2-40B4-BE49-F238E27FC236}">
-                <a16:creationId xmlns:a16="http://schemas.microsoft.com/office/drawing/2014/main" id="{212F2CA8-689F-4E86-0E00-8129788178EB}"/>
+                <a16:creationId xmlns:a16="http://schemas.microsoft.com/office/drawing/2014/main" xmlns="" id="{212F2CA8-689F-4E86-0E00-8129788178EB}"/>
               </a:ext>
             </a:extLst>
           </p:cNvPr>
@@ -11127,7 +11143,7 @@
           <p:cNvPr id="14" name="Shape 8">
             <a:extLst>
               <a:ext uri="{FF2B5EF4-FFF2-40B4-BE49-F238E27FC236}">
-                <a16:creationId xmlns:a16="http://schemas.microsoft.com/office/drawing/2014/main" id="{6C3D1B9A-2413-9DCD-6E24-F69B7AEBC3E3}"/>
+                <a16:creationId xmlns:a16="http://schemas.microsoft.com/office/drawing/2014/main" xmlns="" id="{6C3D1B9A-2413-9DCD-6E24-F69B7AEBC3E3}"/>
               </a:ext>
             </a:extLst>
           </p:cNvPr>
@@ -11165,7 +11181,7 @@
           <p:cNvPr id="15" name="Image 0" descr="preencoded.png">
             <a:extLst>
               <a:ext uri="{FF2B5EF4-FFF2-40B4-BE49-F238E27FC236}">
-                <a16:creationId xmlns:a16="http://schemas.microsoft.com/office/drawing/2014/main" id="{AFFF804E-5108-27CF-70AF-E7E9D27599E6}"/>
+                <a16:creationId xmlns:a16="http://schemas.microsoft.com/office/drawing/2014/main" xmlns="" id="{AFFF804E-5108-27CF-70AF-E7E9D27599E6}"/>
               </a:ext>
             </a:extLst>
           </p:cNvPr>
@@ -11194,7 +11210,7 @@
           <p:cNvPr id="16" name="Shape 9">
             <a:extLst>
               <a:ext uri="{FF2B5EF4-FFF2-40B4-BE49-F238E27FC236}">
-                <a16:creationId xmlns:a16="http://schemas.microsoft.com/office/drawing/2014/main" id="{85769856-3773-39A7-DD62-833C24B07A2A}"/>
+                <a16:creationId xmlns:a16="http://schemas.microsoft.com/office/drawing/2014/main" xmlns="" id="{85769856-3773-39A7-DD62-833C24B07A2A}"/>
               </a:ext>
             </a:extLst>
           </p:cNvPr>
@@ -11225,7 +11241,7 @@
           <p:cNvPr id="17" name="Text 10">
             <a:extLst>
               <a:ext uri="{FF2B5EF4-FFF2-40B4-BE49-F238E27FC236}">
-                <a16:creationId xmlns:a16="http://schemas.microsoft.com/office/drawing/2014/main" id="{8C26610A-57A2-E75E-51AC-BF8D1CD54C5F}"/>
+                <a16:creationId xmlns:a16="http://schemas.microsoft.com/office/drawing/2014/main" xmlns="" id="{8C26610A-57A2-E75E-51AC-BF8D1CD54C5F}"/>
               </a:ext>
             </a:extLst>
           </p:cNvPr>
@@ -11267,7 +11283,7 @@
           <p:cNvPr id="18" name="Text 11">
             <a:extLst>
               <a:ext uri="{FF2B5EF4-FFF2-40B4-BE49-F238E27FC236}">
-                <a16:creationId xmlns:a16="http://schemas.microsoft.com/office/drawing/2014/main" id="{2DF1DC4B-80A7-CD20-6F5F-46F6DA5C73B3}"/>
+                <a16:creationId xmlns:a16="http://schemas.microsoft.com/office/drawing/2014/main" xmlns="" id="{2DF1DC4B-80A7-CD20-6F5F-46F6DA5C73B3}"/>
               </a:ext>
             </a:extLst>
           </p:cNvPr>
@@ -11313,7 +11329,7 @@
           <p:cNvPr id="19" name="Text 12">
             <a:extLst>
               <a:ext uri="{FF2B5EF4-FFF2-40B4-BE49-F238E27FC236}">
-                <a16:creationId xmlns:a16="http://schemas.microsoft.com/office/drawing/2014/main" id="{BCE2E23C-60A8-03D5-28C0-47F97467A236}"/>
+                <a16:creationId xmlns:a16="http://schemas.microsoft.com/office/drawing/2014/main" xmlns="" id="{BCE2E23C-60A8-03D5-28C0-47F97467A236}"/>
               </a:ext>
             </a:extLst>
           </p:cNvPr>
@@ -11359,7 +11375,7 @@
           <p:cNvPr id="20" name="Shape 13">
             <a:extLst>
               <a:ext uri="{FF2B5EF4-FFF2-40B4-BE49-F238E27FC236}">
-                <a16:creationId xmlns:a16="http://schemas.microsoft.com/office/drawing/2014/main" id="{F9C3AD8B-F1EC-FCAE-5338-A2A9A6D465E2}"/>
+                <a16:creationId xmlns:a16="http://schemas.microsoft.com/office/drawing/2014/main" xmlns="" id="{F9C3AD8B-F1EC-FCAE-5338-A2A9A6D465E2}"/>
               </a:ext>
             </a:extLst>
           </p:cNvPr>
@@ -11399,7 +11415,7 @@
           <p:cNvPr id="21" name="Image 1" descr="preencoded.png">
             <a:extLst>
               <a:ext uri="{FF2B5EF4-FFF2-40B4-BE49-F238E27FC236}">
-                <a16:creationId xmlns:a16="http://schemas.microsoft.com/office/drawing/2014/main" id="{8FDCABE6-DB47-0E2B-85FF-83909E39D714}"/>
+                <a16:creationId xmlns:a16="http://schemas.microsoft.com/office/drawing/2014/main" xmlns="" id="{8FDCABE6-DB47-0E2B-85FF-83909E39D714}"/>
               </a:ext>
             </a:extLst>
           </p:cNvPr>
@@ -11431,7 +11447,7 @@
           <p:cNvPr id="22" name="Shape 14">
             <a:extLst>
               <a:ext uri="{FF2B5EF4-FFF2-40B4-BE49-F238E27FC236}">
-                <a16:creationId xmlns:a16="http://schemas.microsoft.com/office/drawing/2014/main" id="{E68F2C29-2AE3-9DEE-7853-C224996AD51C}"/>
+                <a16:creationId xmlns:a16="http://schemas.microsoft.com/office/drawing/2014/main" xmlns="" id="{E68F2C29-2AE3-9DEE-7853-C224996AD51C}"/>
               </a:ext>
             </a:extLst>
           </p:cNvPr>
@@ -11466,7 +11482,7 @@
           <p:cNvPr id="23" name="Text 15">
             <a:extLst>
               <a:ext uri="{FF2B5EF4-FFF2-40B4-BE49-F238E27FC236}">
-                <a16:creationId xmlns:a16="http://schemas.microsoft.com/office/drawing/2014/main" id="{0C54384D-CEB8-C8A5-A4D7-4C117408C317}"/>
+                <a16:creationId xmlns:a16="http://schemas.microsoft.com/office/drawing/2014/main" xmlns="" id="{0C54384D-CEB8-C8A5-A4D7-4C117408C317}"/>
               </a:ext>
             </a:extLst>
           </p:cNvPr>
@@ -11508,7 +11524,7 @@
           <p:cNvPr id="24" name="Text 16">
             <a:extLst>
               <a:ext uri="{FF2B5EF4-FFF2-40B4-BE49-F238E27FC236}">
-                <a16:creationId xmlns:a16="http://schemas.microsoft.com/office/drawing/2014/main" id="{D9B0A7A7-DCD6-F560-4057-C3511816D05F}"/>
+                <a16:creationId xmlns:a16="http://schemas.microsoft.com/office/drawing/2014/main" xmlns="" id="{D9B0A7A7-DCD6-F560-4057-C3511816D05F}"/>
               </a:ext>
             </a:extLst>
           </p:cNvPr>
@@ -11558,7 +11574,7 @@
           <p:cNvPr id="25" name="Text 17">
             <a:extLst>
               <a:ext uri="{FF2B5EF4-FFF2-40B4-BE49-F238E27FC236}">
-                <a16:creationId xmlns:a16="http://schemas.microsoft.com/office/drawing/2014/main" id="{1CB54C08-6656-D789-CFEB-E5CC8577CFF9}"/>
+                <a16:creationId xmlns:a16="http://schemas.microsoft.com/office/drawing/2014/main" xmlns="" id="{1CB54C08-6656-D789-CFEB-E5CC8577CFF9}"/>
               </a:ext>
             </a:extLst>
           </p:cNvPr>
@@ -11608,7 +11624,7 @@
           <p:cNvPr id="26" name="Shape 18">
             <a:extLst>
               <a:ext uri="{FF2B5EF4-FFF2-40B4-BE49-F238E27FC236}">
-                <a16:creationId xmlns:a16="http://schemas.microsoft.com/office/drawing/2014/main" id="{F51D1AD7-FDBB-D88C-3341-0CE21E68991E}"/>
+                <a16:creationId xmlns:a16="http://schemas.microsoft.com/office/drawing/2014/main" xmlns="" id="{F51D1AD7-FDBB-D88C-3341-0CE21E68991E}"/>
               </a:ext>
             </a:extLst>
           </p:cNvPr>
@@ -11646,7 +11662,7 @@
           <p:cNvPr id="27" name="Image 2" descr="preencoded.png">
             <a:extLst>
               <a:ext uri="{FF2B5EF4-FFF2-40B4-BE49-F238E27FC236}">
-                <a16:creationId xmlns:a16="http://schemas.microsoft.com/office/drawing/2014/main" id="{6693F5CB-F6C3-0AE6-8ADA-71F303FD94AA}"/>
+                <a16:creationId xmlns:a16="http://schemas.microsoft.com/office/drawing/2014/main" xmlns="" id="{6693F5CB-F6C3-0AE6-8ADA-71F303FD94AA}"/>
               </a:ext>
             </a:extLst>
           </p:cNvPr>
@@ -11675,7 +11691,7 @@
           <p:cNvPr id="29" name="Text 20">
             <a:extLst>
               <a:ext uri="{FF2B5EF4-FFF2-40B4-BE49-F238E27FC236}">
-                <a16:creationId xmlns:a16="http://schemas.microsoft.com/office/drawing/2014/main" id="{F4B10A3A-3BE6-6421-CF3C-1D084B71FF90}"/>
+                <a16:creationId xmlns:a16="http://schemas.microsoft.com/office/drawing/2014/main" xmlns="" id="{F4B10A3A-3BE6-6421-CF3C-1D084B71FF90}"/>
               </a:ext>
             </a:extLst>
           </p:cNvPr>
@@ -11723,7 +11739,7 @@
           <p:cNvPr id="30" name="Text 21">
             <a:extLst>
               <a:ext uri="{FF2B5EF4-FFF2-40B4-BE49-F238E27FC236}">
-                <a16:creationId xmlns:a16="http://schemas.microsoft.com/office/drawing/2014/main" id="{742A33F4-37EB-51C1-358D-868DC7F80D44}"/>
+                <a16:creationId xmlns:a16="http://schemas.microsoft.com/office/drawing/2014/main" xmlns="" id="{742A33F4-37EB-51C1-358D-868DC7F80D44}"/>
               </a:ext>
             </a:extLst>
           </p:cNvPr>
@@ -11769,7 +11785,7 @@
           <p:cNvPr id="31" name="Text 22">
             <a:extLst>
               <a:ext uri="{FF2B5EF4-FFF2-40B4-BE49-F238E27FC236}">
-                <a16:creationId xmlns:a16="http://schemas.microsoft.com/office/drawing/2014/main" id="{5EF65FB3-DF4F-B9D8-A501-3AAC56EC063B}"/>
+                <a16:creationId xmlns:a16="http://schemas.microsoft.com/office/drawing/2014/main" xmlns="" id="{5EF65FB3-DF4F-B9D8-A501-3AAC56EC063B}"/>
               </a:ext>
             </a:extLst>
           </p:cNvPr>
@@ -11815,7 +11831,7 @@
           <p:cNvPr id="3" name="Picture 2">
             <a:extLst>
               <a:ext uri="{FF2B5EF4-FFF2-40B4-BE49-F238E27FC236}">
-                <a16:creationId xmlns:a16="http://schemas.microsoft.com/office/drawing/2014/main" id="{90869FBF-567B-D7E6-CC4F-C11EFA4C2F0A}"/>
+                <a16:creationId xmlns:a16="http://schemas.microsoft.com/office/drawing/2014/main" xmlns="" id="{90869FBF-567B-D7E6-CC4F-C11EFA4C2F0A}"/>
               </a:ext>
             </a:extLst>
           </p:cNvPr>
@@ -11845,7 +11861,7 @@
           <p:cNvPr id="5" name="Picture 4">
             <a:extLst>
               <a:ext uri="{FF2B5EF4-FFF2-40B4-BE49-F238E27FC236}">
-                <a16:creationId xmlns:a16="http://schemas.microsoft.com/office/drawing/2014/main" id="{8DA114F2-7922-77CF-217D-669A96B3E5C2}"/>
+                <a16:creationId xmlns:a16="http://schemas.microsoft.com/office/drawing/2014/main" xmlns="" id="{8DA114F2-7922-77CF-217D-669A96B3E5C2}"/>
               </a:ext>
             </a:extLst>
           </p:cNvPr>
@@ -11875,7 +11891,7 @@
           <p:cNvPr id="11" name="Picture 10">
             <a:extLst>
               <a:ext uri="{FF2B5EF4-FFF2-40B4-BE49-F238E27FC236}">
-                <a16:creationId xmlns:a16="http://schemas.microsoft.com/office/drawing/2014/main" id="{B37BDF62-7B21-B098-EF68-CCE3ED824751}"/>
+                <a16:creationId xmlns:a16="http://schemas.microsoft.com/office/drawing/2014/main" xmlns="" id="{B37BDF62-7B21-B098-EF68-CCE3ED824751}"/>
               </a:ext>
             </a:extLst>
           </p:cNvPr>

</xml_diff>

<commit_message>
Made changes to slide and report
</commit_message>
<xml_diff>
--- a/others/Final slides (G7).pptx
+++ b/others/Final slides (G7).pptx
@@ -126,9 +126,210 @@
   <p1510:revLst>
     <p1510:client id="{40B3B6A0-791A-4F05-BCC7-DF0017EB143F}" v="375" dt="2026-05-03T08:38:38.368"/>
     <p1510:client id="{507D2BB1-334F-454F-9829-F02BCF432E08}" v="10" dt="2026-05-03T12:42:16.781"/>
-    <p1510:client id="{9A0B9D58-4827-41AF-B106-B4735AC24DFB}" v="2" dt="2026-05-03T04:37:07.939"/>
   </p1510:revLst>
 </p1510:revInfo>
+</file>
+
+<file path=ppt/changesInfos/changesInfo1.xml><?xml version="1.0" encoding="utf-8"?>
+<pc:chgInfo xmlns:a="http://schemas.openxmlformats.org/drawingml/2006/main" xmlns:r="http://schemas.openxmlformats.org/officeDocument/2006/relationships" xmlns:ac="http://schemas.microsoft.com/office/drawing/2013/main/command" xmlns:pc="http://schemas.microsoft.com/office/powerpoint/2013/main/command">
+  <pc:docChgLst>
+    <pc:chgData name="Hridika Tuly" userId="1e56f729759dc07c" providerId="LiveId" clId="{6AB80E12-2D8C-4BC6-9264-5518B082E7E9}"/>
+    <pc:docChg chg="undo custSel modSld">
+      <pc:chgData name="Hridika Tuly" userId="1e56f729759dc07c" providerId="LiveId" clId="{6AB80E12-2D8C-4BC6-9264-5518B082E7E9}" dt="2026-05-04T07:50:31.137" v="51" actId="1076"/>
+      <pc:docMkLst>
+        <pc:docMk/>
+      </pc:docMkLst>
+      <pc:sldChg chg="modSp mod">
+        <pc:chgData name="Hridika Tuly" userId="1e56f729759dc07c" providerId="LiveId" clId="{6AB80E12-2D8C-4BC6-9264-5518B082E7E9}" dt="2026-05-04T07:22:27.268" v="30" actId="208"/>
+        <pc:sldMkLst>
+          <pc:docMk/>
+          <pc:sldMk cId="0" sldId="257"/>
+        </pc:sldMkLst>
+        <pc:spChg chg="mod">
+          <ac:chgData name="Hridika Tuly" userId="1e56f729759dc07c" providerId="LiveId" clId="{6AB80E12-2D8C-4BC6-9264-5518B082E7E9}" dt="2026-05-04T07:22:27.268" v="30" actId="208"/>
+          <ac:spMkLst>
+            <pc:docMk/>
+            <pc:sldMk cId="0" sldId="257"/>
+            <ac:spMk id="3" creationId="{00000000-0000-0000-0000-000000000000}"/>
+          </ac:spMkLst>
+        </pc:spChg>
+      </pc:sldChg>
+      <pc:sldChg chg="modSp mod">
+        <pc:chgData name="Hridika Tuly" userId="1e56f729759dc07c" providerId="LiveId" clId="{6AB80E12-2D8C-4BC6-9264-5518B082E7E9}" dt="2026-05-04T07:48:43.839" v="37" actId="20577"/>
+        <pc:sldMkLst>
+          <pc:docMk/>
+          <pc:sldMk cId="0" sldId="259"/>
+        </pc:sldMkLst>
+        <pc:spChg chg="mod">
+          <ac:chgData name="Hridika Tuly" userId="1e56f729759dc07c" providerId="LiveId" clId="{6AB80E12-2D8C-4BC6-9264-5518B082E7E9}" dt="2026-05-04T07:19:54.685" v="19" actId="208"/>
+          <ac:spMkLst>
+            <pc:docMk/>
+            <pc:sldMk cId="0" sldId="259"/>
+            <ac:spMk id="3" creationId="{00000000-0000-0000-0000-000000000000}"/>
+          </ac:spMkLst>
+        </pc:spChg>
+        <pc:spChg chg="mod">
+          <ac:chgData name="Hridika Tuly" userId="1e56f729759dc07c" providerId="LiveId" clId="{6AB80E12-2D8C-4BC6-9264-5518B082E7E9}" dt="2026-05-04T07:21:25.724" v="25" actId="207"/>
+          <ac:spMkLst>
+            <pc:docMk/>
+            <pc:sldMk cId="0" sldId="259"/>
+            <ac:spMk id="10" creationId="{00000000-0000-0000-0000-000000000000}"/>
+          </ac:spMkLst>
+        </pc:spChg>
+        <pc:spChg chg="mod">
+          <ac:chgData name="Hridika Tuly" userId="1e56f729759dc07c" providerId="LiveId" clId="{6AB80E12-2D8C-4BC6-9264-5518B082E7E9}" dt="2026-05-04T07:21:34.104" v="26" actId="207"/>
+          <ac:spMkLst>
+            <pc:docMk/>
+            <pc:sldMk cId="0" sldId="259"/>
+            <ac:spMk id="11" creationId="{00000000-0000-0000-0000-000000000000}"/>
+          </ac:spMkLst>
+        </pc:spChg>
+        <pc:spChg chg="mod">
+          <ac:chgData name="Hridika Tuly" userId="1e56f729759dc07c" providerId="LiveId" clId="{6AB80E12-2D8C-4BC6-9264-5518B082E7E9}" dt="2026-05-04T07:21:43.683" v="27" actId="207"/>
+          <ac:spMkLst>
+            <pc:docMk/>
+            <pc:sldMk cId="0" sldId="259"/>
+            <ac:spMk id="12" creationId="{00000000-0000-0000-0000-000000000000}"/>
+          </ac:spMkLst>
+        </pc:spChg>
+        <pc:spChg chg="mod">
+          <ac:chgData name="Hridika Tuly" userId="1e56f729759dc07c" providerId="LiveId" clId="{6AB80E12-2D8C-4BC6-9264-5518B082E7E9}" dt="2026-05-04T07:21:52.633" v="28" actId="207"/>
+          <ac:spMkLst>
+            <pc:docMk/>
+            <pc:sldMk cId="0" sldId="259"/>
+            <ac:spMk id="13" creationId="{00000000-0000-0000-0000-000000000000}"/>
+          </ac:spMkLst>
+        </pc:spChg>
+        <pc:spChg chg="mod">
+          <ac:chgData name="Hridika Tuly" userId="1e56f729759dc07c" providerId="LiveId" clId="{6AB80E12-2D8C-4BC6-9264-5518B082E7E9}" dt="2026-05-04T07:22:00.086" v="29" actId="207"/>
+          <ac:spMkLst>
+            <pc:docMk/>
+            <pc:sldMk cId="0" sldId="259"/>
+            <ac:spMk id="14" creationId="{00000000-0000-0000-0000-000000000000}"/>
+          </ac:spMkLst>
+        </pc:spChg>
+        <pc:spChg chg="mod">
+          <ac:chgData name="Hridika Tuly" userId="1e56f729759dc07c" providerId="LiveId" clId="{6AB80E12-2D8C-4BC6-9264-5518B082E7E9}" dt="2026-05-04T07:20:39.081" v="23" actId="1076"/>
+          <ac:spMkLst>
+            <pc:docMk/>
+            <pc:sldMk cId="0" sldId="259"/>
+            <ac:spMk id="27" creationId="{00000000-0000-0000-0000-000000000000}"/>
+          </ac:spMkLst>
+        </pc:spChg>
+        <pc:spChg chg="mod">
+          <ac:chgData name="Hridika Tuly" userId="1e56f729759dc07c" providerId="LiveId" clId="{6AB80E12-2D8C-4BC6-9264-5518B082E7E9}" dt="2026-05-04T07:19:41.749" v="16" actId="207"/>
+          <ac:spMkLst>
+            <pc:docMk/>
+            <pc:sldMk cId="0" sldId="259"/>
+            <ac:spMk id="32" creationId="{00000000-0000-0000-0000-000000000000}"/>
+          </ac:spMkLst>
+        </pc:spChg>
+        <pc:spChg chg="mod">
+          <ac:chgData name="Hridika Tuly" userId="1e56f729759dc07c" providerId="LiveId" clId="{6AB80E12-2D8C-4BC6-9264-5518B082E7E9}" dt="2026-05-04T07:19:46.703" v="17" actId="207"/>
+          <ac:spMkLst>
+            <pc:docMk/>
+            <pc:sldMk cId="0" sldId="259"/>
+            <ac:spMk id="33" creationId="{00000000-0000-0000-0000-000000000000}"/>
+          </ac:spMkLst>
+        </pc:spChg>
+        <pc:spChg chg="mod">
+          <ac:chgData name="Hridika Tuly" userId="1e56f729759dc07c" providerId="LiveId" clId="{6AB80E12-2D8C-4BC6-9264-5518B082E7E9}" dt="2026-05-04T07:20:33.533" v="21" actId="207"/>
+          <ac:spMkLst>
+            <pc:docMk/>
+            <pc:sldMk cId="0" sldId="259"/>
+            <ac:spMk id="34" creationId="{00000000-0000-0000-0000-000000000000}"/>
+          </ac:spMkLst>
+        </pc:spChg>
+        <pc:spChg chg="mod">
+          <ac:chgData name="Hridika Tuly" userId="1e56f729759dc07c" providerId="LiveId" clId="{6AB80E12-2D8C-4BC6-9264-5518B082E7E9}" dt="2026-05-04T07:20:45.723" v="24" actId="207"/>
+          <ac:spMkLst>
+            <pc:docMk/>
+            <pc:sldMk cId="0" sldId="259"/>
+            <ac:spMk id="35" creationId="{00000000-0000-0000-0000-000000000000}"/>
+          </ac:spMkLst>
+        </pc:spChg>
+        <pc:spChg chg="mod">
+          <ac:chgData name="Hridika Tuly" userId="1e56f729759dc07c" providerId="LiveId" clId="{6AB80E12-2D8C-4BC6-9264-5518B082E7E9}" dt="2026-05-04T07:48:43.839" v="37" actId="20577"/>
+          <ac:spMkLst>
+            <pc:docMk/>
+            <pc:sldMk cId="0" sldId="259"/>
+            <ac:spMk id="36" creationId="{00000000-0000-0000-0000-000000000000}"/>
+          </ac:spMkLst>
+        </pc:spChg>
+      </pc:sldChg>
+      <pc:sldChg chg="modSp mod">
+        <pc:chgData name="Hridika Tuly" userId="1e56f729759dc07c" providerId="LiveId" clId="{6AB80E12-2D8C-4BC6-9264-5518B082E7E9}" dt="2026-05-04T07:48:53.412" v="39" actId="20577"/>
+        <pc:sldMkLst>
+          <pc:docMk/>
+          <pc:sldMk cId="0" sldId="260"/>
+        </pc:sldMkLst>
+        <pc:spChg chg="mod">
+          <ac:chgData name="Hridika Tuly" userId="1e56f729759dc07c" providerId="LiveId" clId="{6AB80E12-2D8C-4BC6-9264-5518B082E7E9}" dt="2026-05-04T07:20:01.689" v="20" actId="208"/>
+          <ac:spMkLst>
+            <pc:docMk/>
+            <pc:sldMk cId="0" sldId="260"/>
+            <ac:spMk id="3" creationId="{00000000-0000-0000-0000-000000000000}"/>
+          </ac:spMkLst>
+        </pc:spChg>
+        <pc:spChg chg="mod">
+          <ac:chgData name="Hridika Tuly" userId="1e56f729759dc07c" providerId="LiveId" clId="{6AB80E12-2D8C-4BC6-9264-5518B082E7E9}" dt="2026-05-04T07:48:53.412" v="39" actId="20577"/>
+          <ac:spMkLst>
+            <pc:docMk/>
+            <pc:sldMk cId="0" sldId="260"/>
+            <ac:spMk id="20" creationId="{00000000-0000-0000-0000-000000000000}"/>
+          </ac:spMkLst>
+        </pc:spChg>
+      </pc:sldChg>
+      <pc:sldChg chg="addSp delSp modSp mod">
+        <pc:chgData name="Hridika Tuly" userId="1e56f729759dc07c" providerId="LiveId" clId="{6AB80E12-2D8C-4BC6-9264-5518B082E7E9}" dt="2026-05-04T07:50:31.137" v="51" actId="1076"/>
+        <pc:sldMkLst>
+          <pc:docMk/>
+          <pc:sldMk cId="423410264" sldId="271"/>
+        </pc:sldMkLst>
+        <pc:picChg chg="add del mod">
+          <ac:chgData name="Hridika Tuly" userId="1e56f729759dc07c" providerId="LiveId" clId="{6AB80E12-2D8C-4BC6-9264-5518B082E7E9}" dt="2026-05-04T07:49:22.720" v="41" actId="478"/>
+          <ac:picMkLst>
+            <pc:docMk/>
+            <pc:sldMk cId="423410264" sldId="271"/>
+            <ac:picMk id="7" creationId="{59DEF14B-C499-E070-0849-07D347DDCF54}"/>
+          </ac:picMkLst>
+        </pc:picChg>
+        <pc:picChg chg="add mod">
+          <ac:chgData name="Hridika Tuly" userId="1e56f729759dc07c" providerId="LiveId" clId="{6AB80E12-2D8C-4BC6-9264-5518B082E7E9}" dt="2026-05-04T07:49:55.845" v="44" actId="1076"/>
+          <ac:picMkLst>
+            <pc:docMk/>
+            <pc:sldMk cId="423410264" sldId="271"/>
+            <ac:picMk id="9" creationId="{6FA2F84E-CE79-B9F5-59F8-195995AE89E4}"/>
+          </ac:picMkLst>
+        </pc:picChg>
+        <pc:picChg chg="del">
+          <ac:chgData name="Hridika Tuly" userId="1e56f729759dc07c" providerId="LiveId" clId="{6AB80E12-2D8C-4BC6-9264-5518B082E7E9}" dt="2026-05-04T07:49:21.266" v="40" actId="478"/>
+          <ac:picMkLst>
+            <pc:docMk/>
+            <pc:sldMk cId="423410264" sldId="271"/>
+            <ac:picMk id="10" creationId="{A3755DDE-D646-8E4F-2DE7-4DB81715C688}"/>
+          </ac:picMkLst>
+        </pc:picChg>
+        <pc:picChg chg="add mod">
+          <ac:chgData name="Hridika Tuly" userId="1e56f729759dc07c" providerId="LiveId" clId="{6AB80E12-2D8C-4BC6-9264-5518B082E7E9}" dt="2026-05-04T07:50:31.137" v="51" actId="1076"/>
+          <ac:picMkLst>
+            <pc:docMk/>
+            <pc:sldMk cId="423410264" sldId="271"/>
+            <ac:picMk id="13" creationId="{1AA365B1-2763-FE25-21A0-2B9834D7682D}"/>
+          </ac:picMkLst>
+        </pc:picChg>
+        <pc:picChg chg="del">
+          <ac:chgData name="Hridika Tuly" userId="1e56f729759dc07c" providerId="LiveId" clId="{6AB80E12-2D8C-4BC6-9264-5518B082E7E9}" dt="2026-05-04T06:47:42.038" v="0" actId="478"/>
+          <ac:picMkLst>
+            <pc:docMk/>
+            <pc:sldMk cId="423410264" sldId="271"/>
+            <ac:picMk id="14" creationId="{FBD04FA8-C69A-10BF-0779-23E4163C9B4D}"/>
+          </ac:picMkLst>
+        </pc:picChg>
+      </pc:sldChg>
+    </pc:docChg>
+  </pc:docChgLst>
+</pc:chgInfo>
 </file>
 
 <file path=ppt/notesMasters/notesMaster1.xml><?xml version="1.0" encoding="utf-8"?>
@@ -212,7 +413,7 @@
           </a:lstStyle>
           <a:p>
             <a:fld id="{489D2C63-CB8E-4C69-BFB6-9AC9D8C1CA13}" type="datetimeFigureOut">
-              <a:t>04-May-26</a:t>
+              <a:t>5/4/2026</a:t>
             </a:fld>
             <a:endParaRPr lang="en-US"/>
           </a:p>
@@ -1232,7 +1433,7 @@
           <p:cNvPr id="2" name="Shape 0">
             <a:extLst>
               <a:ext uri="{FF2B5EF4-FFF2-40B4-BE49-F238E27FC236}">
-                <a16:creationId xmlns:a16="http://schemas.microsoft.com/office/drawing/2014/main" xmlns="" id="{07D48B70-643E-5398-0182-63939169A457}"/>
+                <a16:creationId xmlns:a16="http://schemas.microsoft.com/office/drawing/2014/main" id="{07D48B70-643E-5398-0182-63939169A457}"/>
               </a:ext>
             </a:extLst>
           </p:cNvPr>
@@ -1263,7 +1464,7 @@
           <p:cNvPr id="3" name="Shape 1">
             <a:extLst>
               <a:ext uri="{FF2B5EF4-FFF2-40B4-BE49-F238E27FC236}">
-                <a16:creationId xmlns:a16="http://schemas.microsoft.com/office/drawing/2014/main" xmlns="" id="{4574CFF8-DDD8-F038-8C17-129AB18155EF}"/>
+                <a16:creationId xmlns:a16="http://schemas.microsoft.com/office/drawing/2014/main" id="{4574CFF8-DDD8-F038-8C17-129AB18155EF}"/>
               </a:ext>
             </a:extLst>
           </p:cNvPr>
@@ -1297,7 +1498,7 @@
           <p:cNvPr id="4" name="Shape 2">
             <a:extLst>
               <a:ext uri="{FF2B5EF4-FFF2-40B4-BE49-F238E27FC236}">
-                <a16:creationId xmlns:a16="http://schemas.microsoft.com/office/drawing/2014/main" xmlns="" id="{7CD5AEA1-D504-0CA3-4EA4-0978F9FE7805}"/>
+                <a16:creationId xmlns:a16="http://schemas.microsoft.com/office/drawing/2014/main" id="{7CD5AEA1-D504-0CA3-4EA4-0978F9FE7805}"/>
               </a:ext>
             </a:extLst>
           </p:cNvPr>
@@ -1328,7 +1529,7 @@
           <p:cNvPr id="5" name="Shape 3">
             <a:extLst>
               <a:ext uri="{FF2B5EF4-FFF2-40B4-BE49-F238E27FC236}">
-                <a16:creationId xmlns:a16="http://schemas.microsoft.com/office/drawing/2014/main" xmlns="" id="{27857ADF-E943-3CC1-B247-52D96FE7BF83}"/>
+                <a16:creationId xmlns:a16="http://schemas.microsoft.com/office/drawing/2014/main" id="{27857ADF-E943-3CC1-B247-52D96FE7BF83}"/>
               </a:ext>
             </a:extLst>
           </p:cNvPr>
@@ -1359,7 +1560,7 @@
           <p:cNvPr id="6" name="Shape 4">
             <a:extLst>
               <a:ext uri="{FF2B5EF4-FFF2-40B4-BE49-F238E27FC236}">
-                <a16:creationId xmlns:a16="http://schemas.microsoft.com/office/drawing/2014/main" xmlns="" id="{7025232F-30E9-7C9B-D4AE-E64A06388532}"/>
+                <a16:creationId xmlns:a16="http://schemas.microsoft.com/office/drawing/2014/main" id="{7025232F-30E9-7C9B-D4AE-E64A06388532}"/>
               </a:ext>
             </a:extLst>
           </p:cNvPr>
@@ -1397,7 +1598,7 @@
           <p:cNvPr id="7" name="Text 5">
             <a:extLst>
               <a:ext uri="{FF2B5EF4-FFF2-40B4-BE49-F238E27FC236}">
-                <a16:creationId xmlns:a16="http://schemas.microsoft.com/office/drawing/2014/main" xmlns="" id="{04A4207A-655C-C7DE-CCF7-A2F88B8C5478}"/>
+                <a16:creationId xmlns:a16="http://schemas.microsoft.com/office/drawing/2014/main" id="{04A4207A-655C-C7DE-CCF7-A2F88B8C5478}"/>
               </a:ext>
             </a:extLst>
           </p:cNvPr>
@@ -1450,7 +1651,7 @@
           <p:cNvPr id="8" name="Text 6">
             <a:extLst>
               <a:ext uri="{FF2B5EF4-FFF2-40B4-BE49-F238E27FC236}">
-                <a16:creationId xmlns:a16="http://schemas.microsoft.com/office/drawing/2014/main" xmlns="" id="{C94884A8-64C3-2A91-547A-4DCAF760B5FF}"/>
+                <a16:creationId xmlns:a16="http://schemas.microsoft.com/office/drawing/2014/main" id="{C94884A8-64C3-2A91-547A-4DCAF760B5FF}"/>
               </a:ext>
             </a:extLst>
           </p:cNvPr>
@@ -1512,7 +1713,7 @@
           <p:cNvPr id="9" name="Text 7">
             <a:extLst>
               <a:ext uri="{FF2B5EF4-FFF2-40B4-BE49-F238E27FC236}">
-                <a16:creationId xmlns:a16="http://schemas.microsoft.com/office/drawing/2014/main" xmlns="" id="{724CEEA7-46D3-F02E-74B4-62F7BF7F63A6}"/>
+                <a16:creationId xmlns:a16="http://schemas.microsoft.com/office/drawing/2014/main" id="{724CEEA7-46D3-F02E-74B4-62F7BF7F63A6}"/>
               </a:ext>
             </a:extLst>
           </p:cNvPr>
@@ -1567,7 +1768,7 @@
           <p:cNvPr id="10" name="Text 8">
             <a:extLst>
               <a:ext uri="{FF2B5EF4-FFF2-40B4-BE49-F238E27FC236}">
-                <a16:creationId xmlns:a16="http://schemas.microsoft.com/office/drawing/2014/main" xmlns="" id="{F4404318-C77A-05BA-AF98-2E278907F1CD}"/>
+                <a16:creationId xmlns:a16="http://schemas.microsoft.com/office/drawing/2014/main" id="{F4404318-C77A-05BA-AF98-2E278907F1CD}"/>
               </a:ext>
             </a:extLst>
           </p:cNvPr>
@@ -1609,7 +1810,7 @@
           <p:cNvPr id="11" name="Shape 9">
             <a:extLst>
               <a:ext uri="{FF2B5EF4-FFF2-40B4-BE49-F238E27FC236}">
-                <a16:creationId xmlns:a16="http://schemas.microsoft.com/office/drawing/2014/main" xmlns="" id="{9B017DC0-D0EC-4426-3A6C-8F1D5F34C22B}"/>
+                <a16:creationId xmlns:a16="http://schemas.microsoft.com/office/drawing/2014/main" id="{9B017DC0-D0EC-4426-3A6C-8F1D5F34C22B}"/>
               </a:ext>
             </a:extLst>
           </p:cNvPr>
@@ -1646,7 +1847,7 @@
           <p:cNvPr id="12" name="Text 10">
             <a:extLst>
               <a:ext uri="{FF2B5EF4-FFF2-40B4-BE49-F238E27FC236}">
-                <a16:creationId xmlns:a16="http://schemas.microsoft.com/office/drawing/2014/main" xmlns="" id="{FCE5AC94-2920-21F3-9882-3E4528B0DE96}"/>
+                <a16:creationId xmlns:a16="http://schemas.microsoft.com/office/drawing/2014/main" id="{FCE5AC94-2920-21F3-9882-3E4528B0DE96}"/>
               </a:ext>
             </a:extLst>
           </p:cNvPr>
@@ -1688,7 +1889,7 @@
           <p:cNvPr id="13" name="Text 11">
             <a:extLst>
               <a:ext uri="{FF2B5EF4-FFF2-40B4-BE49-F238E27FC236}">
-                <a16:creationId xmlns:a16="http://schemas.microsoft.com/office/drawing/2014/main" xmlns="" id="{ACAAC472-DA27-C564-8F9C-6333BF7E6F28}"/>
+                <a16:creationId xmlns:a16="http://schemas.microsoft.com/office/drawing/2014/main" id="{ACAAC472-DA27-C564-8F9C-6333BF7E6F28}"/>
               </a:ext>
             </a:extLst>
           </p:cNvPr>
@@ -1730,7 +1931,7 @@
           <p:cNvPr id="14" name="Text 12">
             <a:extLst>
               <a:ext uri="{FF2B5EF4-FFF2-40B4-BE49-F238E27FC236}">
-                <a16:creationId xmlns:a16="http://schemas.microsoft.com/office/drawing/2014/main" xmlns="" id="{068C93DC-21C0-A14F-3AE7-AB51A5EE5E2B}"/>
+                <a16:creationId xmlns:a16="http://schemas.microsoft.com/office/drawing/2014/main" id="{068C93DC-21C0-A14F-3AE7-AB51A5EE5E2B}"/>
               </a:ext>
             </a:extLst>
           </p:cNvPr>
@@ -1772,7 +1973,7 @@
           <p:cNvPr id="15" name="Image 0" descr="preencoded.png">
             <a:extLst>
               <a:ext uri="{FF2B5EF4-FFF2-40B4-BE49-F238E27FC236}">
-                <a16:creationId xmlns:a16="http://schemas.microsoft.com/office/drawing/2014/main" xmlns="" id="{2240F1F3-CEA7-CD8E-D86F-7CCBC6A4BD73}"/>
+                <a16:creationId xmlns:a16="http://schemas.microsoft.com/office/drawing/2014/main" id="{2240F1F3-CEA7-CD8E-D86F-7CCBC6A4BD73}"/>
               </a:ext>
             </a:extLst>
           </p:cNvPr>
@@ -1811,7 +2012,7 @@
           <p:cNvPr id="16" name="Shape 13">
             <a:extLst>
               <a:ext uri="{FF2B5EF4-FFF2-40B4-BE49-F238E27FC236}">
-                <a16:creationId xmlns:a16="http://schemas.microsoft.com/office/drawing/2014/main" xmlns="" id="{2463A389-9F67-992B-6DAD-FDB571A10A23}"/>
+                <a16:creationId xmlns:a16="http://schemas.microsoft.com/office/drawing/2014/main" id="{2463A389-9F67-992B-6DAD-FDB571A10A23}"/>
               </a:ext>
             </a:extLst>
           </p:cNvPr>
@@ -1839,7 +2040,7 @@
           <p:cNvPr id="17" name="Image 1" descr="preencoded.png">
             <a:extLst>
               <a:ext uri="{FF2B5EF4-FFF2-40B4-BE49-F238E27FC236}">
-                <a16:creationId xmlns:a16="http://schemas.microsoft.com/office/drawing/2014/main" xmlns="" id="{99EDCC59-7008-EE42-9469-32E7861AE591}"/>
+                <a16:creationId xmlns:a16="http://schemas.microsoft.com/office/drawing/2014/main" id="{99EDCC59-7008-EE42-9469-32E7861AE591}"/>
               </a:ext>
             </a:extLst>
           </p:cNvPr>
@@ -1873,7 +2074,7 @@
           <p:cNvPr id="18" name="Shape 14">
             <a:extLst>
               <a:ext uri="{FF2B5EF4-FFF2-40B4-BE49-F238E27FC236}">
-                <a16:creationId xmlns:a16="http://schemas.microsoft.com/office/drawing/2014/main" xmlns="" id="{A4B4A26E-8DBD-388C-4803-88287B071883}"/>
+                <a16:creationId xmlns:a16="http://schemas.microsoft.com/office/drawing/2014/main" id="{A4B4A26E-8DBD-388C-4803-88287B071883}"/>
               </a:ext>
             </a:extLst>
           </p:cNvPr>
@@ -1901,7 +2102,7 @@
           <p:cNvPr id="26" name="Picture 25">
             <a:extLst>
               <a:ext uri="{FF2B5EF4-FFF2-40B4-BE49-F238E27FC236}">
-                <a16:creationId xmlns:a16="http://schemas.microsoft.com/office/drawing/2014/main" xmlns="" id="{699CC631-D84F-E098-C402-339DDB4E55F9}"/>
+                <a16:creationId xmlns:a16="http://schemas.microsoft.com/office/drawing/2014/main" id="{699CC631-D84F-E098-C402-339DDB4E55F9}"/>
               </a:ext>
             </a:extLst>
           </p:cNvPr>
@@ -1931,7 +2132,7 @@
           <p:cNvPr id="30" name="Picture 29">
             <a:extLst>
               <a:ext uri="{FF2B5EF4-FFF2-40B4-BE49-F238E27FC236}">
-                <a16:creationId xmlns:a16="http://schemas.microsoft.com/office/drawing/2014/main" xmlns="" id="{F9C3B992-46BC-562E-59F9-2CDCDD52440C}"/>
+                <a16:creationId xmlns:a16="http://schemas.microsoft.com/office/drawing/2014/main" id="{F9C3B992-46BC-562E-59F9-2CDCDD52440C}"/>
               </a:ext>
             </a:extLst>
           </p:cNvPr>
@@ -1991,7 +2192,7 @@
           <p:cNvPr id="4" name="Shape 2">
             <a:extLst>
               <a:ext uri="{FF2B5EF4-FFF2-40B4-BE49-F238E27FC236}">
-                <a16:creationId xmlns:a16="http://schemas.microsoft.com/office/drawing/2014/main" xmlns="" id="{081EB42C-7403-8C44-5105-9393B8AA65E4}"/>
+                <a16:creationId xmlns:a16="http://schemas.microsoft.com/office/drawing/2014/main" id="{081EB42C-7403-8C44-5105-9393B8AA65E4}"/>
               </a:ext>
             </a:extLst>
           </p:cNvPr>
@@ -2022,7 +2223,7 @@
           <p:cNvPr id="5" name="Text 3">
             <a:extLst>
               <a:ext uri="{FF2B5EF4-FFF2-40B4-BE49-F238E27FC236}">
-                <a16:creationId xmlns:a16="http://schemas.microsoft.com/office/drawing/2014/main" xmlns="" id="{E69B80E3-F4FC-E0F4-8123-DAA496876E66}"/>
+                <a16:creationId xmlns:a16="http://schemas.microsoft.com/office/drawing/2014/main" id="{E69B80E3-F4FC-E0F4-8123-DAA496876E66}"/>
               </a:ext>
             </a:extLst>
           </p:cNvPr>
@@ -2067,7 +2268,7 @@
           <p:cNvPr id="6" name="Shape 4">
             <a:extLst>
               <a:ext uri="{FF2B5EF4-FFF2-40B4-BE49-F238E27FC236}">
-                <a16:creationId xmlns:a16="http://schemas.microsoft.com/office/drawing/2014/main" xmlns="" id="{CFC7EB49-3639-FF74-F162-53864F05A9EF}"/>
+                <a16:creationId xmlns:a16="http://schemas.microsoft.com/office/drawing/2014/main" id="{CFC7EB49-3639-FF74-F162-53864F05A9EF}"/>
               </a:ext>
             </a:extLst>
           </p:cNvPr>
@@ -2098,7 +2299,7 @@
           <p:cNvPr id="8" name="Text 6">
             <a:extLst>
               <a:ext uri="{FF2B5EF4-FFF2-40B4-BE49-F238E27FC236}">
-                <a16:creationId xmlns:a16="http://schemas.microsoft.com/office/drawing/2014/main" xmlns="" id="{2E4B7429-F6EB-0B10-8A7B-5509B557F297}"/>
+                <a16:creationId xmlns:a16="http://schemas.microsoft.com/office/drawing/2014/main" id="{2E4B7429-F6EB-0B10-8A7B-5509B557F297}"/>
               </a:ext>
             </a:extLst>
           </p:cNvPr>
@@ -2140,7 +2341,7 @@
           <p:cNvPr id="9" name="Text 7">
             <a:extLst>
               <a:ext uri="{FF2B5EF4-FFF2-40B4-BE49-F238E27FC236}">
-                <a16:creationId xmlns:a16="http://schemas.microsoft.com/office/drawing/2014/main" xmlns="" id="{53802D0E-EFD4-300F-3091-CBB1B597AC03}"/>
+                <a16:creationId xmlns:a16="http://schemas.microsoft.com/office/drawing/2014/main" id="{53802D0E-EFD4-300F-3091-CBB1B597AC03}"/>
               </a:ext>
             </a:extLst>
           </p:cNvPr>
@@ -2182,7 +2383,7 @@
           <p:cNvPr id="10" name="Text 8">
             <a:extLst>
               <a:ext uri="{FF2B5EF4-FFF2-40B4-BE49-F238E27FC236}">
-                <a16:creationId xmlns:a16="http://schemas.microsoft.com/office/drawing/2014/main" xmlns="" id="{1DB08042-FFBC-2202-971B-21A6DD0401E5}"/>
+                <a16:creationId xmlns:a16="http://schemas.microsoft.com/office/drawing/2014/main" id="{1DB08042-FFBC-2202-971B-21A6DD0401E5}"/>
               </a:ext>
             </a:extLst>
           </p:cNvPr>
@@ -2301,7 +2502,7 @@
           </a:solidFill>
           <a:ln w="12700">
             <a:solidFill>
-              <a:srgbClr val="F4631E"/>
+              <a:schemeClr val="accent2"/>
             </a:solidFill>
             <a:prstDash val="solid"/>
           </a:ln>
@@ -4857,7 +5058,7 @@
           </a:solidFill>
           <a:ln w="12700">
             <a:solidFill>
-              <a:srgbClr val="7C3AED"/>
+              <a:schemeClr val="accent2"/>
             </a:solidFill>
             <a:prstDash val="solid"/>
           </a:ln>
@@ -5036,12 +5237,13 @@
             <a:r>
               <a:rPr lang="en-US" sz="1000" dirty="0">
                 <a:solidFill>
-                  <a:srgbClr val="4A5568"/>
+                  <a:schemeClr val="accent5">
+                    <a:lumMod val="50000"/>
+                  </a:schemeClr>
                 </a:solidFill>
               </a:rPr>
               <a:t>D-Fire (20K)</a:t>
             </a:r>
-            <a:endParaRPr lang="en-US" sz="1000" dirty="0"/>
           </a:p>
         </p:txBody>
       </p:sp>
@@ -5080,12 +5282,13 @@
             <a:r>
               <a:rPr lang="en-US" sz="1000" dirty="0">
                 <a:solidFill>
-                  <a:srgbClr val="4A5568"/>
+                  <a:schemeClr val="accent5">
+                    <a:lumMod val="50000"/>
+                  </a:schemeClr>
                 </a:solidFill>
               </a:rPr>
               <a:t>Indoor Fire (8K)</a:t>
             </a:r>
-            <a:endParaRPr lang="en-US" sz="1000" dirty="0"/>
           </a:p>
         </p:txBody>
       </p:sp>
@@ -5116,7 +5319,9 @@
             <a:r>
               <a:rPr lang="en-US" sz="1000" b="1" dirty="0">
                 <a:solidFill>
-                  <a:srgbClr val="F4631E"/>
+                  <a:schemeClr val="accent5">
+                    <a:lumMod val="50000"/>
+                  </a:schemeClr>
                 </a:solidFill>
               </a:rPr>
               <a:t>  </a:t>
@@ -5124,12 +5329,13 @@
             <a:r>
               <a:rPr lang="en-US" sz="1000" dirty="0">
                 <a:solidFill>
-                  <a:srgbClr val="4A5568"/>
+                  <a:schemeClr val="accent5">
+                    <a:lumMod val="50000"/>
+                  </a:schemeClr>
                 </a:solidFill>
               </a:rPr>
               <a:t>Flame-BD (2K)</a:t>
             </a:r>
-            <a:endParaRPr lang="en-US" sz="1000" dirty="0"/>
           </a:p>
         </p:txBody>
       </p:sp>
@@ -5168,12 +5374,13 @@
             <a:r>
               <a:rPr lang="en-US" sz="1000" dirty="0">
                 <a:solidFill>
-                  <a:srgbClr val="4A5568"/>
+                  <a:schemeClr val="accent5">
+                    <a:lumMod val="50000"/>
+                  </a:schemeClr>
                 </a:solidFill>
               </a:rPr>
               <a:t>Iron Wolf (15K)</a:t>
             </a:r>
-            <a:endParaRPr lang="en-US" sz="1000" dirty="0"/>
           </a:p>
         </p:txBody>
       </p:sp>
@@ -5212,12 +5419,13 @@
             <a:r>
               <a:rPr lang="en-US" sz="1000" dirty="0">
                 <a:solidFill>
-                  <a:srgbClr val="4A5568"/>
+                  <a:schemeClr val="accent5">
+                    <a:lumMod val="50000"/>
+                  </a:schemeClr>
                 </a:solidFill>
               </a:rPr>
               <a:t>45,252 total images</a:t>
             </a:r>
-            <a:endParaRPr lang="en-US" sz="1000" dirty="0"/>
           </a:p>
         </p:txBody>
       </p:sp>
@@ -5834,12 +6042,13 @@
             <a:r>
               <a:rPr lang="en-US" sz="1000" dirty="0">
                 <a:solidFill>
-                  <a:srgbClr val="4A5568"/>
+                  <a:schemeClr val="accent5">
+                    <a:lumMod val="50000"/>
+                  </a:schemeClr>
                 </a:solidFill>
               </a:rPr>
               <a:t>YOLOv8n vs YOLOv8s</a:t>
             </a:r>
-            <a:endParaRPr lang="en-US" sz="1000" dirty="0"/>
           </a:p>
         </p:txBody>
       </p:sp>
@@ -5878,12 +6087,13 @@
             <a:r>
               <a:rPr lang="en-US" sz="1000" dirty="0">
                 <a:solidFill>
-                  <a:srgbClr val="4A5568"/>
+                  <a:schemeClr val="accent5">
+                    <a:lumMod val="50000"/>
+                  </a:schemeClr>
                 </a:solidFill>
               </a:rPr>
               <a:t>Epoch sweep: 45</a:t>
             </a:r>
-            <a:endParaRPr lang="en-US" sz="1000" dirty="0"/>
           </a:p>
         </p:txBody>
       </p:sp>
@@ -5917,17 +6127,28 @@
                   <a:srgbClr val="7C3AED"/>
                 </a:solidFill>
               </a:rPr>
-              <a:t>  </a:t>
-            </a:r>
-            <a:r>
-              <a:rPr lang="en-US" sz="1000">
-                <a:solidFill>
-                  <a:srgbClr val="4A5568"/>
+              <a:t> </a:t>
+            </a:r>
+            <a:r>
+              <a:rPr lang="en-US" sz="1000" b="1" dirty="0">
+                <a:solidFill>
+                  <a:schemeClr val="accent5">
+                    <a:lumMod val="50000"/>
+                  </a:schemeClr>
+                </a:solidFill>
+              </a:rPr>
+              <a:t> </a:t>
+            </a:r>
+            <a:r>
+              <a:rPr lang="en-US" sz="1000" dirty="0">
+                <a:solidFill>
+                  <a:schemeClr val="accent5">
+                    <a:lumMod val="50000"/>
+                  </a:schemeClr>
                 </a:solidFill>
               </a:rPr>
               <a:t>Batch size: 32</a:t>
             </a:r>
-            <a:endParaRPr lang="en-US" sz="1000"/>
           </a:p>
         </p:txBody>
       </p:sp>
@@ -5960,26 +6181,42 @@
                 <a:ea typeface="Calibri"/>
                 <a:cs typeface="Calibri"/>
               </a:rPr>
-              <a:t>  Linear </a:t>
-            </a:r>
-            <a:r>
-              <a:rPr lang="en-US" sz="1000" dirty="0" err="1">
-                <a:solidFill>
-                  <a:srgbClr val="4A5568"/>
+              <a:t>  </a:t>
+            </a:r>
+            <a:r>
+              <a:rPr lang="en-US" sz="1000" dirty="0">
+                <a:solidFill>
+                  <a:schemeClr val="accent5">
+                    <a:lumMod val="50000"/>
+                  </a:schemeClr>
                 </a:solidFill>
                 <a:ea typeface="Calibri"/>
                 <a:cs typeface="Calibri"/>
               </a:rPr>
-              <a:t>lr</a:t>
-            </a:r>
-            <a:r>
-              <a:rPr lang="en-US" sz="1000" dirty="0">
-                <a:solidFill>
-                  <a:srgbClr val="4A5568"/>
+              <a:t>Linear </a:t>
+            </a:r>
+            <a:r>
+              <a:rPr lang="en-US" sz="1000" dirty="0" err="1">
+                <a:solidFill>
+                  <a:schemeClr val="accent5">
+                    <a:lumMod val="50000"/>
+                  </a:schemeClr>
                 </a:solidFill>
                 <a:ea typeface="Calibri"/>
                 <a:cs typeface="Calibri"/>
               </a:rPr>
+              <a:t>lr</a:t>
+            </a:r>
+            <a:r>
+              <a:rPr lang="en-US" sz="1000" dirty="0">
+                <a:solidFill>
+                  <a:schemeClr val="accent5">
+                    <a:lumMod val="50000"/>
+                  </a:schemeClr>
+                </a:solidFill>
+                <a:ea typeface="Calibri"/>
+                <a:cs typeface="Calibri"/>
+              </a:rPr>
               <a:t>: 0.01</a:t>
             </a:r>
           </a:p>
@@ -6006,26 +6243,26 @@
           <a:bodyPr wrap="square" lIns="0" tIns="0" rIns="0" bIns="0" rtlCol="0" anchor="ctr"/>
           <a:lstStyle/>
           <a:p>
-            <a:pPr marL="0" indent="0">
-              <a:buNone/>
-            </a:pPr>
-            <a:r>
-              <a:rPr lang="en-US" sz="1000" b="1" dirty="0">
-                <a:solidFill>
-                  <a:srgbClr val="7C3AED"/>
-                </a:solidFill>
-              </a:rPr>
-              <a:t>  </a:t>
+            <a:r>
+              <a:rPr lang="en-US" sz="1000" dirty="0" err="1">
+                <a:solidFill>
+                  <a:schemeClr val="accent5">
+                    <a:lumMod val="50000"/>
+                  </a:schemeClr>
+                </a:solidFill>
+              </a:rPr>
+              <a:t>MuSGD</a:t>
             </a:r>
             <a:r>
               <a:rPr lang="en-US" sz="1000" dirty="0">
                 <a:solidFill>
-                  <a:srgbClr val="4A5568"/>
-                </a:solidFill>
-              </a:rPr>
-              <a:t>SGD momentum 0.937</a:t>
-            </a:r>
-            <a:endParaRPr lang="en-US" sz="1000" dirty="0"/>
+                  <a:schemeClr val="accent5">
+                    <a:lumMod val="50000"/>
+                  </a:schemeClr>
+                </a:solidFill>
+              </a:rPr>
+              <a:t> momentum 0.937</a:t>
+            </a:r>
           </a:p>
         </p:txBody>
       </p:sp>
@@ -6472,7 +6709,7 @@
           <p:cNvPr id="48" name="Shape 14">
             <a:extLst>
               <a:ext uri="{FF2B5EF4-FFF2-40B4-BE49-F238E27FC236}">
-                <a16:creationId xmlns:a16="http://schemas.microsoft.com/office/drawing/2014/main" xmlns="" id="{45D457CD-DFEE-363E-4E33-AD417E43FA81}"/>
+                <a16:creationId xmlns:a16="http://schemas.microsoft.com/office/drawing/2014/main" id="{45D457CD-DFEE-363E-4E33-AD417E43FA81}"/>
               </a:ext>
             </a:extLst>
           </p:cNvPr>
@@ -6507,7 +6744,7 @@
           <p:cNvPr id="50" name="TextBox 49">
             <a:extLst>
               <a:ext uri="{FF2B5EF4-FFF2-40B4-BE49-F238E27FC236}">
-                <a16:creationId xmlns:a16="http://schemas.microsoft.com/office/drawing/2014/main" xmlns="" id="{5D858DAB-CD0D-AAD0-789A-D4B5BE908DA3}"/>
+                <a16:creationId xmlns:a16="http://schemas.microsoft.com/office/drawing/2014/main" id="{5D858DAB-CD0D-AAD0-789A-D4B5BE908DA3}"/>
               </a:ext>
             </a:extLst>
           </p:cNvPr>
@@ -6547,7 +6784,7 @@
           <p:cNvPr id="51" name="Image 0" descr="preencoded.png">
             <a:extLst>
               <a:ext uri="{FF2B5EF4-FFF2-40B4-BE49-F238E27FC236}">
-                <a16:creationId xmlns:a16="http://schemas.microsoft.com/office/drawing/2014/main" xmlns="" id="{08445E86-6AD4-AA7D-1A6D-9705D3705983}"/>
+                <a16:creationId xmlns:a16="http://schemas.microsoft.com/office/drawing/2014/main" id="{08445E86-6AD4-AA7D-1A6D-9705D3705983}"/>
               </a:ext>
             </a:extLst>
           </p:cNvPr>
@@ -6585,7 +6822,7 @@
           <p:cNvPr id="54" name="TextBox 53">
             <a:extLst>
               <a:ext uri="{FF2B5EF4-FFF2-40B4-BE49-F238E27FC236}">
-                <a16:creationId xmlns:a16="http://schemas.microsoft.com/office/drawing/2014/main" xmlns="" id="{063B844F-8708-12FF-B2D5-57AE20B79092}"/>
+                <a16:creationId xmlns:a16="http://schemas.microsoft.com/office/drawing/2014/main" id="{063B844F-8708-12FF-B2D5-57AE20B79092}"/>
               </a:ext>
             </a:extLst>
           </p:cNvPr>
@@ -6625,7 +6862,7 @@
           <p:cNvPr id="56" name="Picture 55">
             <a:extLst>
               <a:ext uri="{FF2B5EF4-FFF2-40B4-BE49-F238E27FC236}">
-                <a16:creationId xmlns:a16="http://schemas.microsoft.com/office/drawing/2014/main" xmlns="" id="{8679AA37-90D8-6919-7C0F-7C0FB310C94C}"/>
+                <a16:creationId xmlns:a16="http://schemas.microsoft.com/office/drawing/2014/main" id="{8679AA37-90D8-6919-7C0F-7C0FB310C94C}"/>
               </a:ext>
             </a:extLst>
           </p:cNvPr>
@@ -6735,7 +6972,7 @@
           </a:solidFill>
           <a:ln w="12700">
             <a:solidFill>
-              <a:srgbClr val="F59E0B"/>
+              <a:schemeClr val="accent2"/>
             </a:solidFill>
             <a:prstDash val="solid"/>
           </a:ln>
@@ -7256,28 +7493,20 @@
               <a:buNone/>
             </a:pPr>
             <a:r>
-              <a:rPr lang="en-US" sz="1050" b="1" dirty="0" err="1" smtClean="0">
+              <a:rPr lang="en-US" sz="1050" b="1" dirty="0" err="1">
                 <a:solidFill>
                   <a:srgbClr val="002060"/>
                 </a:solidFill>
               </a:rPr>
-              <a:t>AdamW</a:t>
-            </a:r>
-            <a:r>
-              <a:rPr lang="en-US" sz="1050" b="1" smtClean="0">
+              <a:t>MuSGD</a:t>
+            </a:r>
+            <a:r>
+              <a:rPr lang="en-US" sz="1050" b="1" dirty="0">
                 <a:solidFill>
                   <a:srgbClr val="002060"/>
                 </a:solidFill>
               </a:rPr>
-              <a:t> (momentum </a:t>
-            </a:r>
-            <a:r>
-              <a:rPr lang="en-US" sz="1050" b="1" dirty="0">
-                <a:solidFill>
-                  <a:srgbClr val="002060"/>
-                </a:solidFill>
-              </a:rPr>
-              <a:t>= 0.937)</a:t>
+              <a:t>  (momentum = 0.937)</a:t>
             </a:r>
             <a:endParaRPr lang="en-US" sz="1050" dirty="0">
               <a:solidFill>
@@ -9032,7 +9261,7 @@
           <p:cNvPr id="4" name="Shape 0">
             <a:extLst>
               <a:ext uri="{FF2B5EF4-FFF2-40B4-BE49-F238E27FC236}">
-                <a16:creationId xmlns:a16="http://schemas.microsoft.com/office/drawing/2014/main" xmlns="" id="{A9B983E9-266B-EB54-46CA-44F44B186A0B}"/>
+                <a16:creationId xmlns:a16="http://schemas.microsoft.com/office/drawing/2014/main" id="{A9B983E9-266B-EB54-46CA-44F44B186A0B}"/>
               </a:ext>
             </a:extLst>
           </p:cNvPr>
@@ -9063,7 +9292,7 @@
           <p:cNvPr id="6" name="Shape 1">
             <a:extLst>
               <a:ext uri="{FF2B5EF4-FFF2-40B4-BE49-F238E27FC236}">
-                <a16:creationId xmlns:a16="http://schemas.microsoft.com/office/drawing/2014/main" xmlns="" id="{7CBB8927-4B2A-0387-315A-F32CB3D45CBB}"/>
+                <a16:creationId xmlns:a16="http://schemas.microsoft.com/office/drawing/2014/main" id="{7CBB8927-4B2A-0387-315A-F32CB3D45CBB}"/>
               </a:ext>
             </a:extLst>
           </p:cNvPr>
@@ -9094,7 +9323,7 @@
           <p:cNvPr id="8" name="Text 2">
             <a:extLst>
               <a:ext uri="{FF2B5EF4-FFF2-40B4-BE49-F238E27FC236}">
-                <a16:creationId xmlns:a16="http://schemas.microsoft.com/office/drawing/2014/main" xmlns="" id="{3C155AA2-0A7B-E685-B78C-A1A93A3E9188}"/>
+                <a16:creationId xmlns:a16="http://schemas.microsoft.com/office/drawing/2014/main" id="{3C155AA2-0A7B-E685-B78C-A1A93A3E9188}"/>
               </a:ext>
             </a:extLst>
           </p:cNvPr>
@@ -9133,7 +9362,7 @@
           <p:cNvPr id="12" name="Text 4">
             <a:extLst>
               <a:ext uri="{FF2B5EF4-FFF2-40B4-BE49-F238E27FC236}">
-                <a16:creationId xmlns:a16="http://schemas.microsoft.com/office/drawing/2014/main" xmlns="" id="{E09060B9-7ABF-1B5E-C84D-77B799AB0FF2}"/>
+                <a16:creationId xmlns:a16="http://schemas.microsoft.com/office/drawing/2014/main" id="{E09060B9-7ABF-1B5E-C84D-77B799AB0FF2}"/>
               </a:ext>
             </a:extLst>
           </p:cNvPr>
@@ -9167,7 +9396,7 @@
           <p:cNvPr id="14" name="Shape 5">
             <a:extLst>
               <a:ext uri="{FF2B5EF4-FFF2-40B4-BE49-F238E27FC236}">
-                <a16:creationId xmlns:a16="http://schemas.microsoft.com/office/drawing/2014/main" xmlns="" id="{D27125F7-0419-FC86-72D2-C85A972EA7BF}"/>
+                <a16:creationId xmlns:a16="http://schemas.microsoft.com/office/drawing/2014/main" id="{D27125F7-0419-FC86-72D2-C85A972EA7BF}"/>
               </a:ext>
             </a:extLst>
           </p:cNvPr>
@@ -9205,7 +9434,7 @@
           <p:cNvPr id="16" name="Shape 6">
             <a:extLst>
               <a:ext uri="{FF2B5EF4-FFF2-40B4-BE49-F238E27FC236}">
-                <a16:creationId xmlns:a16="http://schemas.microsoft.com/office/drawing/2014/main" xmlns="" id="{D7D554AB-FECA-3EBA-BC1E-E52F6B89EBA8}"/>
+                <a16:creationId xmlns:a16="http://schemas.microsoft.com/office/drawing/2014/main" id="{D7D554AB-FECA-3EBA-BC1E-E52F6B89EBA8}"/>
               </a:ext>
             </a:extLst>
           </p:cNvPr>
@@ -9236,7 +9465,7 @@
           <p:cNvPr id="18" name="Text 7">
             <a:extLst>
               <a:ext uri="{FF2B5EF4-FFF2-40B4-BE49-F238E27FC236}">
-                <a16:creationId xmlns:a16="http://schemas.microsoft.com/office/drawing/2014/main" xmlns="" id="{CC1409BF-FF70-4634-FB58-223431E16051}"/>
+                <a16:creationId xmlns:a16="http://schemas.microsoft.com/office/drawing/2014/main" id="{CC1409BF-FF70-4634-FB58-223431E16051}"/>
               </a:ext>
             </a:extLst>
           </p:cNvPr>
@@ -9282,7 +9511,7 @@
           <p:cNvPr id="20" name="Text 8">
             <a:extLst>
               <a:ext uri="{FF2B5EF4-FFF2-40B4-BE49-F238E27FC236}">
-                <a16:creationId xmlns:a16="http://schemas.microsoft.com/office/drawing/2014/main" xmlns="" id="{8614140E-E9C4-E693-49D2-31A1F730D3C1}"/>
+                <a16:creationId xmlns:a16="http://schemas.microsoft.com/office/drawing/2014/main" id="{8614140E-E9C4-E693-49D2-31A1F730D3C1}"/>
               </a:ext>
             </a:extLst>
           </p:cNvPr>
@@ -9323,7 +9552,7 @@
           <p:cNvPr id="22" name="Text 9">
             <a:extLst>
               <a:ext uri="{FF2B5EF4-FFF2-40B4-BE49-F238E27FC236}">
-                <a16:creationId xmlns:a16="http://schemas.microsoft.com/office/drawing/2014/main" xmlns="" id="{23DB82E1-B8A9-3E9B-4386-6438C324BB7D}"/>
+                <a16:creationId xmlns:a16="http://schemas.microsoft.com/office/drawing/2014/main" id="{23DB82E1-B8A9-3E9B-4386-6438C324BB7D}"/>
               </a:ext>
             </a:extLst>
           </p:cNvPr>
@@ -9369,7 +9598,7 @@
           <p:cNvPr id="24" name="Shape 10">
             <a:extLst>
               <a:ext uri="{FF2B5EF4-FFF2-40B4-BE49-F238E27FC236}">
-                <a16:creationId xmlns:a16="http://schemas.microsoft.com/office/drawing/2014/main" xmlns="" id="{397642C4-F4B8-0F11-6993-EF73BDFF22C9}"/>
+                <a16:creationId xmlns:a16="http://schemas.microsoft.com/office/drawing/2014/main" id="{397642C4-F4B8-0F11-6993-EF73BDFF22C9}"/>
               </a:ext>
             </a:extLst>
           </p:cNvPr>
@@ -9407,7 +9636,7 @@
           <p:cNvPr id="26" name="Shape 11">
             <a:extLst>
               <a:ext uri="{FF2B5EF4-FFF2-40B4-BE49-F238E27FC236}">
-                <a16:creationId xmlns:a16="http://schemas.microsoft.com/office/drawing/2014/main" xmlns="" id="{4BB7A93B-5A96-4574-E757-56FED3382705}"/>
+                <a16:creationId xmlns:a16="http://schemas.microsoft.com/office/drawing/2014/main" id="{4BB7A93B-5A96-4574-E757-56FED3382705}"/>
               </a:ext>
             </a:extLst>
           </p:cNvPr>
@@ -9442,7 +9671,7 @@
           <p:cNvPr id="28" name="Text 12">
             <a:extLst>
               <a:ext uri="{FF2B5EF4-FFF2-40B4-BE49-F238E27FC236}">
-                <a16:creationId xmlns:a16="http://schemas.microsoft.com/office/drawing/2014/main" xmlns="" id="{71F04ECE-8D9A-6D09-1A85-F7AC7BD14F40}"/>
+                <a16:creationId xmlns:a16="http://schemas.microsoft.com/office/drawing/2014/main" id="{71F04ECE-8D9A-6D09-1A85-F7AC7BD14F40}"/>
               </a:ext>
             </a:extLst>
           </p:cNvPr>
@@ -9492,7 +9721,7 @@
           <p:cNvPr id="30" name="Text 13">
             <a:extLst>
               <a:ext uri="{FF2B5EF4-FFF2-40B4-BE49-F238E27FC236}">
-                <a16:creationId xmlns:a16="http://schemas.microsoft.com/office/drawing/2014/main" xmlns="" id="{4E586FD9-EA2A-D2F9-04E5-E62E7F931A26}"/>
+                <a16:creationId xmlns:a16="http://schemas.microsoft.com/office/drawing/2014/main" id="{4E586FD9-EA2A-D2F9-04E5-E62E7F931A26}"/>
               </a:ext>
             </a:extLst>
           </p:cNvPr>
@@ -9535,7 +9764,7 @@
           <p:cNvPr id="32" name="Text 14">
             <a:extLst>
               <a:ext uri="{FF2B5EF4-FFF2-40B4-BE49-F238E27FC236}">
-                <a16:creationId xmlns:a16="http://schemas.microsoft.com/office/drawing/2014/main" xmlns="" id="{1F92A777-AA14-0B79-D43D-FA5B1D0FC955}"/>
+                <a16:creationId xmlns:a16="http://schemas.microsoft.com/office/drawing/2014/main" id="{1F92A777-AA14-0B79-D43D-FA5B1D0FC955}"/>
               </a:ext>
             </a:extLst>
           </p:cNvPr>
@@ -9585,7 +9814,7 @@
           <p:cNvPr id="34" name="Shape 15">
             <a:extLst>
               <a:ext uri="{FF2B5EF4-FFF2-40B4-BE49-F238E27FC236}">
-                <a16:creationId xmlns:a16="http://schemas.microsoft.com/office/drawing/2014/main" xmlns="" id="{A162135A-4153-EB67-5B86-46F84B323566}"/>
+                <a16:creationId xmlns:a16="http://schemas.microsoft.com/office/drawing/2014/main" id="{A162135A-4153-EB67-5B86-46F84B323566}"/>
               </a:ext>
             </a:extLst>
           </p:cNvPr>
@@ -9623,7 +9852,7 @@
           <p:cNvPr id="36" name="Shape 16">
             <a:extLst>
               <a:ext uri="{FF2B5EF4-FFF2-40B4-BE49-F238E27FC236}">
-                <a16:creationId xmlns:a16="http://schemas.microsoft.com/office/drawing/2014/main" xmlns="" id="{7EDFE522-5306-9424-7551-D4727D9DDAA2}"/>
+                <a16:creationId xmlns:a16="http://schemas.microsoft.com/office/drawing/2014/main" id="{7EDFE522-5306-9424-7551-D4727D9DDAA2}"/>
               </a:ext>
             </a:extLst>
           </p:cNvPr>
@@ -9654,7 +9883,7 @@
           <p:cNvPr id="38" name="Text 17">
             <a:extLst>
               <a:ext uri="{FF2B5EF4-FFF2-40B4-BE49-F238E27FC236}">
-                <a16:creationId xmlns:a16="http://schemas.microsoft.com/office/drawing/2014/main" xmlns="" id="{81A7B3A1-A2B9-AE1B-5A95-D9A47EFDA002}"/>
+                <a16:creationId xmlns:a16="http://schemas.microsoft.com/office/drawing/2014/main" id="{81A7B3A1-A2B9-AE1B-5A95-D9A47EFDA002}"/>
               </a:ext>
             </a:extLst>
           </p:cNvPr>
@@ -9696,7 +9925,7 @@
           <p:cNvPr id="40" name="Text 18">
             <a:extLst>
               <a:ext uri="{FF2B5EF4-FFF2-40B4-BE49-F238E27FC236}">
-                <a16:creationId xmlns:a16="http://schemas.microsoft.com/office/drawing/2014/main" xmlns="" id="{BCE65E42-74A1-A067-5148-48712EDE627B}"/>
+                <a16:creationId xmlns:a16="http://schemas.microsoft.com/office/drawing/2014/main" id="{BCE65E42-74A1-A067-5148-48712EDE627B}"/>
               </a:ext>
             </a:extLst>
           </p:cNvPr>
@@ -9737,7 +9966,7 @@
           <p:cNvPr id="42" name="Text 19">
             <a:extLst>
               <a:ext uri="{FF2B5EF4-FFF2-40B4-BE49-F238E27FC236}">
-                <a16:creationId xmlns:a16="http://schemas.microsoft.com/office/drawing/2014/main" xmlns="" id="{9F30EFB7-2B85-D92B-9F5C-E743943AA52D}"/>
+                <a16:creationId xmlns:a16="http://schemas.microsoft.com/office/drawing/2014/main" id="{9F30EFB7-2B85-D92B-9F5C-E743943AA52D}"/>
               </a:ext>
             </a:extLst>
           </p:cNvPr>
@@ -9783,7 +10012,7 @@
           <p:cNvPr id="44" name="Text 23">
             <a:extLst>
               <a:ext uri="{FF2B5EF4-FFF2-40B4-BE49-F238E27FC236}">
-                <a16:creationId xmlns:a16="http://schemas.microsoft.com/office/drawing/2014/main" xmlns="" id="{430EE856-E098-590D-88D6-DDDCA8556376}"/>
+                <a16:creationId xmlns:a16="http://schemas.microsoft.com/office/drawing/2014/main" id="{430EE856-E098-590D-88D6-DDDCA8556376}"/>
               </a:ext>
             </a:extLst>
           </p:cNvPr>
@@ -9823,7 +10052,7 @@
           <p:cNvPr id="46" name="Text 24">
             <a:extLst>
               <a:ext uri="{FF2B5EF4-FFF2-40B4-BE49-F238E27FC236}">
-                <a16:creationId xmlns:a16="http://schemas.microsoft.com/office/drawing/2014/main" xmlns="" id="{3B54CC46-439A-2AF6-2B73-2A14D57DB847}"/>
+                <a16:creationId xmlns:a16="http://schemas.microsoft.com/office/drawing/2014/main" id="{3B54CC46-439A-2AF6-2B73-2A14D57DB847}"/>
               </a:ext>
             </a:extLst>
           </p:cNvPr>
@@ -9865,7 +10094,7 @@
           <p:cNvPr id="2" name="Shape 5">
             <a:extLst>
               <a:ext uri="{FF2B5EF4-FFF2-40B4-BE49-F238E27FC236}">
-                <a16:creationId xmlns:a16="http://schemas.microsoft.com/office/drawing/2014/main" xmlns="" id="{AD60ECD7-D4DB-DD67-1EA6-14113B6BE56C}"/>
+                <a16:creationId xmlns:a16="http://schemas.microsoft.com/office/drawing/2014/main" id="{AD60ECD7-D4DB-DD67-1EA6-14113B6BE56C}"/>
               </a:ext>
             </a:extLst>
           </p:cNvPr>
@@ -9903,7 +10132,7 @@
           <p:cNvPr id="3" name="Shape 6">
             <a:extLst>
               <a:ext uri="{FF2B5EF4-FFF2-40B4-BE49-F238E27FC236}">
-                <a16:creationId xmlns:a16="http://schemas.microsoft.com/office/drawing/2014/main" xmlns="" id="{A0989504-9BED-DABB-8862-FCD5758716C2}"/>
+                <a16:creationId xmlns:a16="http://schemas.microsoft.com/office/drawing/2014/main" id="{A0989504-9BED-DABB-8862-FCD5758716C2}"/>
               </a:ext>
             </a:extLst>
           </p:cNvPr>
@@ -9934,7 +10163,7 @@
           <p:cNvPr id="5" name="Text 7">
             <a:extLst>
               <a:ext uri="{FF2B5EF4-FFF2-40B4-BE49-F238E27FC236}">
-                <a16:creationId xmlns:a16="http://schemas.microsoft.com/office/drawing/2014/main" xmlns="" id="{D4E9740B-47C4-0051-E55F-35557016CAB7}"/>
+                <a16:creationId xmlns:a16="http://schemas.microsoft.com/office/drawing/2014/main" id="{D4E9740B-47C4-0051-E55F-35557016CAB7}"/>
               </a:ext>
             </a:extLst>
           </p:cNvPr>
@@ -9980,7 +10209,7 @@
           <p:cNvPr id="7" name="Text 8">
             <a:extLst>
               <a:ext uri="{FF2B5EF4-FFF2-40B4-BE49-F238E27FC236}">
-                <a16:creationId xmlns:a16="http://schemas.microsoft.com/office/drawing/2014/main" xmlns="" id="{FAEF54B6-9549-BA02-A2FD-6F7CE10E949E}"/>
+                <a16:creationId xmlns:a16="http://schemas.microsoft.com/office/drawing/2014/main" id="{FAEF54B6-9549-BA02-A2FD-6F7CE10E949E}"/>
               </a:ext>
             </a:extLst>
           </p:cNvPr>
@@ -10021,7 +10250,7 @@
           <p:cNvPr id="9" name="Text 9">
             <a:extLst>
               <a:ext uri="{FF2B5EF4-FFF2-40B4-BE49-F238E27FC236}">
-                <a16:creationId xmlns:a16="http://schemas.microsoft.com/office/drawing/2014/main" xmlns="" id="{03DEB4E6-C6D2-98DD-CF87-4F59DA47C4D1}"/>
+                <a16:creationId xmlns:a16="http://schemas.microsoft.com/office/drawing/2014/main" id="{03DEB4E6-C6D2-98DD-CF87-4F59DA47C4D1}"/>
               </a:ext>
             </a:extLst>
           </p:cNvPr>
@@ -10067,7 +10296,7 @@
           <p:cNvPr id="10" name="Shape 10">
             <a:extLst>
               <a:ext uri="{FF2B5EF4-FFF2-40B4-BE49-F238E27FC236}">
-                <a16:creationId xmlns:a16="http://schemas.microsoft.com/office/drawing/2014/main" xmlns="" id="{B847EB4A-F803-657B-808D-853D4438AFD8}"/>
+                <a16:creationId xmlns:a16="http://schemas.microsoft.com/office/drawing/2014/main" id="{B847EB4A-F803-657B-808D-853D4438AFD8}"/>
               </a:ext>
             </a:extLst>
           </p:cNvPr>
@@ -10105,7 +10334,7 @@
           <p:cNvPr id="11" name="Shape 11">
             <a:extLst>
               <a:ext uri="{FF2B5EF4-FFF2-40B4-BE49-F238E27FC236}">
-                <a16:creationId xmlns:a16="http://schemas.microsoft.com/office/drawing/2014/main" xmlns="" id="{511DE68E-2A28-BC5C-C813-2A703CB567F4}"/>
+                <a16:creationId xmlns:a16="http://schemas.microsoft.com/office/drawing/2014/main" id="{511DE68E-2A28-BC5C-C813-2A703CB567F4}"/>
               </a:ext>
             </a:extLst>
           </p:cNvPr>
@@ -10140,7 +10369,7 @@
           <p:cNvPr id="13" name="Text 12">
             <a:extLst>
               <a:ext uri="{FF2B5EF4-FFF2-40B4-BE49-F238E27FC236}">
-                <a16:creationId xmlns:a16="http://schemas.microsoft.com/office/drawing/2014/main" xmlns="" id="{62C16DFE-5F1B-CDE0-D6F9-89C3EA8B8BC1}"/>
+                <a16:creationId xmlns:a16="http://schemas.microsoft.com/office/drawing/2014/main" id="{62C16DFE-5F1B-CDE0-D6F9-89C3EA8B8BC1}"/>
               </a:ext>
             </a:extLst>
           </p:cNvPr>
@@ -10190,7 +10419,7 @@
           <p:cNvPr id="15" name="Text 13">
             <a:extLst>
               <a:ext uri="{FF2B5EF4-FFF2-40B4-BE49-F238E27FC236}">
-                <a16:creationId xmlns:a16="http://schemas.microsoft.com/office/drawing/2014/main" xmlns="" id="{B460AC3A-8F82-995D-F1E4-43A7BEE289A7}"/>
+                <a16:creationId xmlns:a16="http://schemas.microsoft.com/office/drawing/2014/main" id="{B460AC3A-8F82-995D-F1E4-43A7BEE289A7}"/>
               </a:ext>
             </a:extLst>
           </p:cNvPr>
@@ -10233,7 +10462,7 @@
           <p:cNvPr id="17" name="Text 14">
             <a:extLst>
               <a:ext uri="{FF2B5EF4-FFF2-40B4-BE49-F238E27FC236}">
-                <a16:creationId xmlns:a16="http://schemas.microsoft.com/office/drawing/2014/main" xmlns="" id="{BFB007C1-2B8A-FD86-0D74-160370E732CA}"/>
+                <a16:creationId xmlns:a16="http://schemas.microsoft.com/office/drawing/2014/main" id="{BFB007C1-2B8A-FD86-0D74-160370E732CA}"/>
               </a:ext>
             </a:extLst>
           </p:cNvPr>
@@ -10283,7 +10512,7 @@
           <p:cNvPr id="19" name="Shape 15">
             <a:extLst>
               <a:ext uri="{FF2B5EF4-FFF2-40B4-BE49-F238E27FC236}">
-                <a16:creationId xmlns:a16="http://schemas.microsoft.com/office/drawing/2014/main" xmlns="" id="{34508471-F64D-874E-41BE-6E5F2AE2838D}"/>
+                <a16:creationId xmlns:a16="http://schemas.microsoft.com/office/drawing/2014/main" id="{34508471-F64D-874E-41BE-6E5F2AE2838D}"/>
               </a:ext>
             </a:extLst>
           </p:cNvPr>
@@ -10321,7 +10550,7 @@
           <p:cNvPr id="21" name="Shape 16">
             <a:extLst>
               <a:ext uri="{FF2B5EF4-FFF2-40B4-BE49-F238E27FC236}">
-                <a16:creationId xmlns:a16="http://schemas.microsoft.com/office/drawing/2014/main" xmlns="" id="{5EEB45B3-63F5-1F74-A649-AC484F743A87}"/>
+                <a16:creationId xmlns:a16="http://schemas.microsoft.com/office/drawing/2014/main" id="{5EEB45B3-63F5-1F74-A649-AC484F743A87}"/>
               </a:ext>
             </a:extLst>
           </p:cNvPr>
@@ -10352,7 +10581,7 @@
           <p:cNvPr id="23" name="Text 17">
             <a:extLst>
               <a:ext uri="{FF2B5EF4-FFF2-40B4-BE49-F238E27FC236}">
-                <a16:creationId xmlns:a16="http://schemas.microsoft.com/office/drawing/2014/main" xmlns="" id="{8AB67B1D-9644-3F64-CDEA-31AE7992317F}"/>
+                <a16:creationId xmlns:a16="http://schemas.microsoft.com/office/drawing/2014/main" id="{8AB67B1D-9644-3F64-CDEA-31AE7992317F}"/>
               </a:ext>
             </a:extLst>
           </p:cNvPr>
@@ -10394,7 +10623,7 @@
           <p:cNvPr id="25" name="Text 18">
             <a:extLst>
               <a:ext uri="{FF2B5EF4-FFF2-40B4-BE49-F238E27FC236}">
-                <a16:creationId xmlns:a16="http://schemas.microsoft.com/office/drawing/2014/main" xmlns="" id="{317EAB13-E8FD-8480-75BA-3F7AD126D6F5}"/>
+                <a16:creationId xmlns:a16="http://schemas.microsoft.com/office/drawing/2014/main" id="{317EAB13-E8FD-8480-75BA-3F7AD126D6F5}"/>
               </a:ext>
             </a:extLst>
           </p:cNvPr>
@@ -10435,7 +10664,7 @@
           <p:cNvPr id="27" name="Text 19">
             <a:extLst>
               <a:ext uri="{FF2B5EF4-FFF2-40B4-BE49-F238E27FC236}">
-                <a16:creationId xmlns:a16="http://schemas.microsoft.com/office/drawing/2014/main" xmlns="" id="{8E29360E-3165-BF7A-A929-802DFA45E6A2}"/>
+                <a16:creationId xmlns:a16="http://schemas.microsoft.com/office/drawing/2014/main" id="{8E29360E-3165-BF7A-A929-802DFA45E6A2}"/>
               </a:ext>
             </a:extLst>
           </p:cNvPr>
@@ -10481,7 +10710,7 @@
           <p:cNvPr id="29" name="Text 23">
             <a:extLst>
               <a:ext uri="{FF2B5EF4-FFF2-40B4-BE49-F238E27FC236}">
-                <a16:creationId xmlns:a16="http://schemas.microsoft.com/office/drawing/2014/main" xmlns="" id="{D8BEC7E4-45FE-0C64-2D92-5F038A51E4FB}"/>
+                <a16:creationId xmlns:a16="http://schemas.microsoft.com/office/drawing/2014/main" id="{D8BEC7E4-45FE-0C64-2D92-5F038A51E4FB}"/>
               </a:ext>
             </a:extLst>
           </p:cNvPr>
@@ -10521,7 +10750,7 @@
           <p:cNvPr id="31" name="Text 24">
             <a:extLst>
               <a:ext uri="{FF2B5EF4-FFF2-40B4-BE49-F238E27FC236}">
-                <a16:creationId xmlns:a16="http://schemas.microsoft.com/office/drawing/2014/main" xmlns="" id="{B1414C0C-344E-1CA4-BA30-FBEACDB72686}"/>
+                <a16:creationId xmlns:a16="http://schemas.microsoft.com/office/drawing/2014/main" id="{B1414C0C-344E-1CA4-BA30-FBEACDB72686}"/>
               </a:ext>
             </a:extLst>
           </p:cNvPr>
@@ -10563,7 +10792,7 @@
           <p:cNvPr id="33" name="TextBox 32">
             <a:extLst>
               <a:ext uri="{FF2B5EF4-FFF2-40B4-BE49-F238E27FC236}">
-                <a16:creationId xmlns:a16="http://schemas.microsoft.com/office/drawing/2014/main" xmlns="" id="{E1B6D471-F978-75D4-C772-598382F710AF}"/>
+                <a16:creationId xmlns:a16="http://schemas.microsoft.com/office/drawing/2014/main" id="{E1B6D471-F978-75D4-C772-598382F710AF}"/>
               </a:ext>
             </a:extLst>
           </p:cNvPr>
@@ -10607,7 +10836,7 @@
           <p:cNvPr id="35" name="TextBox 34">
             <a:extLst>
               <a:ext uri="{FF2B5EF4-FFF2-40B4-BE49-F238E27FC236}">
-                <a16:creationId xmlns:a16="http://schemas.microsoft.com/office/drawing/2014/main" xmlns="" id="{46772D9D-8E93-284F-2ECD-F152C08CCCF8}"/>
+                <a16:creationId xmlns:a16="http://schemas.microsoft.com/office/drawing/2014/main" id="{46772D9D-8E93-284F-2ECD-F152C08CCCF8}"/>
               </a:ext>
             </a:extLst>
           </p:cNvPr>
@@ -10676,7 +10905,7 @@
           <p:cNvPr id="2" name="Shape 0">
             <a:extLst>
               <a:ext uri="{FF2B5EF4-FFF2-40B4-BE49-F238E27FC236}">
-                <a16:creationId xmlns:a16="http://schemas.microsoft.com/office/drawing/2014/main" xmlns="" id="{E04063A6-8D70-5AF8-5A26-F1274C848864}"/>
+                <a16:creationId xmlns:a16="http://schemas.microsoft.com/office/drawing/2014/main" id="{E04063A6-8D70-5AF8-5A26-F1274C848864}"/>
               </a:ext>
             </a:extLst>
           </p:cNvPr>
@@ -10707,7 +10936,7 @@
           <p:cNvPr id="3" name="Shape 1">
             <a:extLst>
               <a:ext uri="{FF2B5EF4-FFF2-40B4-BE49-F238E27FC236}">
-                <a16:creationId xmlns:a16="http://schemas.microsoft.com/office/drawing/2014/main" xmlns="" id="{C9A9EE38-9834-6B91-8063-9079A5954851}"/>
+                <a16:creationId xmlns:a16="http://schemas.microsoft.com/office/drawing/2014/main" id="{C9A9EE38-9834-6B91-8063-9079A5954851}"/>
               </a:ext>
             </a:extLst>
           </p:cNvPr>
@@ -10738,7 +10967,7 @@
           <p:cNvPr id="4" name="Text 2">
             <a:extLst>
               <a:ext uri="{FF2B5EF4-FFF2-40B4-BE49-F238E27FC236}">
-                <a16:creationId xmlns:a16="http://schemas.microsoft.com/office/drawing/2014/main" xmlns="" id="{C2AC71D3-A93B-44B9-4C07-22BC28D4F235}"/>
+                <a16:creationId xmlns:a16="http://schemas.microsoft.com/office/drawing/2014/main" id="{C2AC71D3-A93B-44B9-4C07-22BC28D4F235}"/>
               </a:ext>
             </a:extLst>
           </p:cNvPr>
@@ -10783,7 +11012,7 @@
           <p:cNvPr id="6" name="Text 5">
             <a:extLst>
               <a:ext uri="{FF2B5EF4-FFF2-40B4-BE49-F238E27FC236}">
-                <a16:creationId xmlns:a16="http://schemas.microsoft.com/office/drawing/2014/main" xmlns="" id="{2787C306-8987-E713-69B8-959F7C434B52}"/>
+                <a16:creationId xmlns:a16="http://schemas.microsoft.com/office/drawing/2014/main" id="{2787C306-8987-E713-69B8-959F7C434B52}"/>
               </a:ext>
             </a:extLst>
           </p:cNvPr>
@@ -10825,7 +11054,7 @@
           <p:cNvPr id="8" name="Text 34">
             <a:extLst>
               <a:ext uri="{FF2B5EF4-FFF2-40B4-BE49-F238E27FC236}">
-                <a16:creationId xmlns:a16="http://schemas.microsoft.com/office/drawing/2014/main" xmlns="" id="{1F3E2AC9-99F2-9C46-C2E4-E76E8AE4E06B}"/>
+                <a16:creationId xmlns:a16="http://schemas.microsoft.com/office/drawing/2014/main" id="{1F3E2AC9-99F2-9C46-C2E4-E76E8AE4E06B}"/>
               </a:ext>
             </a:extLst>
           </p:cNvPr>
@@ -10862,12 +11091,57 @@
           </a:p>
         </p:txBody>
       </p:sp>
+      <p:sp>
+        <p:nvSpPr>
+          <p:cNvPr id="12" name="Text 31">
+            <a:extLst>
+              <a:ext uri="{FF2B5EF4-FFF2-40B4-BE49-F238E27FC236}">
+                <a16:creationId xmlns:a16="http://schemas.microsoft.com/office/drawing/2014/main" id="{9167F0D6-7267-D821-C4F3-0C3FF22F79B5}"/>
+              </a:ext>
+            </a:extLst>
+          </p:cNvPr>
+          <p:cNvSpPr/>
+          <p:nvPr/>
+        </p:nvSpPr>
+        <p:spPr>
+          <a:xfrm>
+            <a:off x="3922776" y="2215134"/>
+            <a:ext cx="1042416" cy="713232"/>
+          </a:xfrm>
+          <a:prstGeom prst="rect">
+            <a:avLst/>
+          </a:prstGeom>
+          <a:noFill/>
+          <a:ln/>
+        </p:spPr>
+        <p:txBody>
+          <a:bodyPr wrap="square" lIns="0" tIns="0" rIns="0" bIns="0" rtlCol="0" anchor="ctr"/>
+          <a:lstStyle/>
+          <a:p>
+            <a:pPr marL="0" indent="0" algn="ctr">
+              <a:buNone/>
+            </a:pPr>
+            <a:r>
+              <a:rPr lang="en-US" sz="2200" b="1" dirty="0">
+                <a:solidFill>
+                  <a:srgbClr val="FFFFFF"/>
+                </a:solidFill>
+                <a:latin typeface="Arial Black" pitchFamily="34" charset="0"/>
+                <a:ea typeface="Arial Black" pitchFamily="34" charset="-122"/>
+                <a:cs typeface="Arial Black" pitchFamily="34" charset="-120"/>
+              </a:rPr>
+              <a:t>VS</a:t>
+            </a:r>
+            <a:endParaRPr lang="en-US" sz="2200" dirty="0"/>
+          </a:p>
+        </p:txBody>
+      </p:sp>
       <p:pic>
         <p:nvPicPr>
-          <p:cNvPr id="10" name="Picture 9">
+          <p:cNvPr id="9" name="Picture 8">
             <a:extLst>
               <a:ext uri="{FF2B5EF4-FFF2-40B4-BE49-F238E27FC236}">
-                <a16:creationId xmlns:a16="http://schemas.microsoft.com/office/drawing/2014/main" xmlns="" id="{A3755DDE-D646-8E4F-2DE7-4DB81715C688}"/>
+                <a16:creationId xmlns:a16="http://schemas.microsoft.com/office/drawing/2014/main" id="{6FA2F84E-CE79-B9F5-59F8-195995AE89E4}"/>
               </a:ext>
             </a:extLst>
           </p:cNvPr>
@@ -10884,65 +11158,20 @@
         </p:blipFill>
         <p:spPr>
           <a:xfrm>
-            <a:off x="397764" y="1220300"/>
-            <a:ext cx="3977640" cy="3191933"/>
+            <a:off x="233656" y="978694"/>
+            <a:ext cx="4338344" cy="3481387"/>
           </a:xfrm>
           <a:prstGeom prst="rect">
             <a:avLst/>
           </a:prstGeom>
         </p:spPr>
       </p:pic>
-      <p:sp>
-        <p:nvSpPr>
-          <p:cNvPr id="12" name="Text 31">
+      <p:pic>
+        <p:nvPicPr>
+          <p:cNvPr id="13" name="Picture 12">
             <a:extLst>
               <a:ext uri="{FF2B5EF4-FFF2-40B4-BE49-F238E27FC236}">
-                <a16:creationId xmlns:a16="http://schemas.microsoft.com/office/drawing/2014/main" xmlns="" id="{9167F0D6-7267-D821-C4F3-0C3FF22F79B5}"/>
-              </a:ext>
-            </a:extLst>
-          </p:cNvPr>
-          <p:cNvSpPr/>
-          <p:nvPr/>
-        </p:nvSpPr>
-        <p:spPr>
-          <a:xfrm>
-            <a:off x="3922776" y="2215134"/>
-            <a:ext cx="1042416" cy="713232"/>
-          </a:xfrm>
-          <a:prstGeom prst="rect">
-            <a:avLst/>
-          </a:prstGeom>
-          <a:noFill/>
-          <a:ln/>
-        </p:spPr>
-        <p:txBody>
-          <a:bodyPr wrap="square" lIns="0" tIns="0" rIns="0" bIns="0" rtlCol="0" anchor="ctr"/>
-          <a:lstStyle/>
-          <a:p>
-            <a:pPr marL="0" indent="0" algn="ctr">
-              <a:buNone/>
-            </a:pPr>
-            <a:r>
-              <a:rPr lang="en-US" sz="2200" b="1" dirty="0">
-                <a:solidFill>
-                  <a:srgbClr val="FFFFFF"/>
-                </a:solidFill>
-                <a:latin typeface="Arial Black" pitchFamily="34" charset="0"/>
-                <a:ea typeface="Arial Black" pitchFamily="34" charset="-122"/>
-                <a:cs typeface="Arial Black" pitchFamily="34" charset="-120"/>
-              </a:rPr>
-              <a:t>VS</a:t>
-            </a:r>
-            <a:endParaRPr lang="en-US" sz="2200" dirty="0"/>
-          </a:p>
-        </p:txBody>
-      </p:sp>
-      <p:pic>
-        <p:nvPicPr>
-          <p:cNvPr id="14" name="Picture 13">
-            <a:extLst>
-              <a:ext uri="{FF2B5EF4-FFF2-40B4-BE49-F238E27FC236}">
-                <a16:creationId xmlns:a16="http://schemas.microsoft.com/office/drawing/2014/main" xmlns="" id="{FBD04FA8-C69A-10BF-0779-23E4163C9B4D}"/>
+                <a16:creationId xmlns:a16="http://schemas.microsoft.com/office/drawing/2014/main" id="{1AA365B1-2763-FE25-21A0-2B9834D7682D}"/>
               </a:ext>
             </a:extLst>
           </p:cNvPr>
@@ -10959,8 +11188,8 @@
         </p:blipFill>
         <p:spPr>
           <a:xfrm>
-            <a:off x="4617720" y="999019"/>
-            <a:ext cx="4269556" cy="3634493"/>
+            <a:off x="4572000" y="948445"/>
+            <a:ext cx="4451306" cy="3516222"/>
           </a:xfrm>
           <a:prstGeom prst="rect">
             <a:avLst/>
@@ -11002,7 +11231,7 @@
           <p:cNvPr id="6" name="Shape 0">
             <a:extLst>
               <a:ext uri="{FF2B5EF4-FFF2-40B4-BE49-F238E27FC236}">
-                <a16:creationId xmlns:a16="http://schemas.microsoft.com/office/drawing/2014/main" xmlns="" id="{918BADE6-7699-2200-D9CE-776695C12927}"/>
+                <a16:creationId xmlns:a16="http://schemas.microsoft.com/office/drawing/2014/main" id="{918BADE6-7699-2200-D9CE-776695C12927}"/>
               </a:ext>
             </a:extLst>
           </p:cNvPr>
@@ -11033,7 +11262,7 @@
           <p:cNvPr id="7" name="Shape 1">
             <a:extLst>
               <a:ext uri="{FF2B5EF4-FFF2-40B4-BE49-F238E27FC236}">
-                <a16:creationId xmlns:a16="http://schemas.microsoft.com/office/drawing/2014/main" xmlns="" id="{4C207137-B9B5-FC77-5DD7-F6F76C67814D}"/>
+                <a16:creationId xmlns:a16="http://schemas.microsoft.com/office/drawing/2014/main" id="{4C207137-B9B5-FC77-5DD7-F6F76C67814D}"/>
               </a:ext>
             </a:extLst>
           </p:cNvPr>
@@ -11064,7 +11293,7 @@
           <p:cNvPr id="8" name="Text 2">
             <a:extLst>
               <a:ext uri="{FF2B5EF4-FFF2-40B4-BE49-F238E27FC236}">
-                <a16:creationId xmlns:a16="http://schemas.microsoft.com/office/drawing/2014/main" xmlns="" id="{821B0063-DDD1-9DEE-AA84-EC7B2019B925}"/>
+                <a16:creationId xmlns:a16="http://schemas.microsoft.com/office/drawing/2014/main" id="{821B0063-DDD1-9DEE-AA84-EC7B2019B925}"/>
               </a:ext>
             </a:extLst>
           </p:cNvPr>
@@ -11109,7 +11338,7 @@
           <p:cNvPr id="10" name="Text 4">
             <a:extLst>
               <a:ext uri="{FF2B5EF4-FFF2-40B4-BE49-F238E27FC236}">
-                <a16:creationId xmlns:a16="http://schemas.microsoft.com/office/drawing/2014/main" xmlns="" id="{212F2CA8-689F-4E86-0E00-8129788178EB}"/>
+                <a16:creationId xmlns:a16="http://schemas.microsoft.com/office/drawing/2014/main" id="{212F2CA8-689F-4E86-0E00-8129788178EB}"/>
               </a:ext>
             </a:extLst>
           </p:cNvPr>
@@ -11143,7 +11372,7 @@
           <p:cNvPr id="14" name="Shape 8">
             <a:extLst>
               <a:ext uri="{FF2B5EF4-FFF2-40B4-BE49-F238E27FC236}">
-                <a16:creationId xmlns:a16="http://schemas.microsoft.com/office/drawing/2014/main" xmlns="" id="{6C3D1B9A-2413-9DCD-6E24-F69B7AEBC3E3}"/>
+                <a16:creationId xmlns:a16="http://schemas.microsoft.com/office/drawing/2014/main" id="{6C3D1B9A-2413-9DCD-6E24-F69B7AEBC3E3}"/>
               </a:ext>
             </a:extLst>
           </p:cNvPr>
@@ -11181,7 +11410,7 @@
           <p:cNvPr id="15" name="Image 0" descr="preencoded.png">
             <a:extLst>
               <a:ext uri="{FF2B5EF4-FFF2-40B4-BE49-F238E27FC236}">
-                <a16:creationId xmlns:a16="http://schemas.microsoft.com/office/drawing/2014/main" xmlns="" id="{AFFF804E-5108-27CF-70AF-E7E9D27599E6}"/>
+                <a16:creationId xmlns:a16="http://schemas.microsoft.com/office/drawing/2014/main" id="{AFFF804E-5108-27CF-70AF-E7E9D27599E6}"/>
               </a:ext>
             </a:extLst>
           </p:cNvPr>
@@ -11210,7 +11439,7 @@
           <p:cNvPr id="16" name="Shape 9">
             <a:extLst>
               <a:ext uri="{FF2B5EF4-FFF2-40B4-BE49-F238E27FC236}">
-                <a16:creationId xmlns:a16="http://schemas.microsoft.com/office/drawing/2014/main" xmlns="" id="{85769856-3773-39A7-DD62-833C24B07A2A}"/>
+                <a16:creationId xmlns:a16="http://schemas.microsoft.com/office/drawing/2014/main" id="{85769856-3773-39A7-DD62-833C24B07A2A}"/>
               </a:ext>
             </a:extLst>
           </p:cNvPr>
@@ -11241,7 +11470,7 @@
           <p:cNvPr id="17" name="Text 10">
             <a:extLst>
               <a:ext uri="{FF2B5EF4-FFF2-40B4-BE49-F238E27FC236}">
-                <a16:creationId xmlns:a16="http://schemas.microsoft.com/office/drawing/2014/main" xmlns="" id="{8C26610A-57A2-E75E-51AC-BF8D1CD54C5F}"/>
+                <a16:creationId xmlns:a16="http://schemas.microsoft.com/office/drawing/2014/main" id="{8C26610A-57A2-E75E-51AC-BF8D1CD54C5F}"/>
               </a:ext>
             </a:extLst>
           </p:cNvPr>
@@ -11283,7 +11512,7 @@
           <p:cNvPr id="18" name="Text 11">
             <a:extLst>
               <a:ext uri="{FF2B5EF4-FFF2-40B4-BE49-F238E27FC236}">
-                <a16:creationId xmlns:a16="http://schemas.microsoft.com/office/drawing/2014/main" xmlns="" id="{2DF1DC4B-80A7-CD20-6F5F-46F6DA5C73B3}"/>
+                <a16:creationId xmlns:a16="http://schemas.microsoft.com/office/drawing/2014/main" id="{2DF1DC4B-80A7-CD20-6F5F-46F6DA5C73B3}"/>
               </a:ext>
             </a:extLst>
           </p:cNvPr>
@@ -11329,7 +11558,7 @@
           <p:cNvPr id="19" name="Text 12">
             <a:extLst>
               <a:ext uri="{FF2B5EF4-FFF2-40B4-BE49-F238E27FC236}">
-                <a16:creationId xmlns:a16="http://schemas.microsoft.com/office/drawing/2014/main" xmlns="" id="{BCE2E23C-60A8-03D5-28C0-47F97467A236}"/>
+                <a16:creationId xmlns:a16="http://schemas.microsoft.com/office/drawing/2014/main" id="{BCE2E23C-60A8-03D5-28C0-47F97467A236}"/>
               </a:ext>
             </a:extLst>
           </p:cNvPr>
@@ -11375,7 +11604,7 @@
           <p:cNvPr id="20" name="Shape 13">
             <a:extLst>
               <a:ext uri="{FF2B5EF4-FFF2-40B4-BE49-F238E27FC236}">
-                <a16:creationId xmlns:a16="http://schemas.microsoft.com/office/drawing/2014/main" xmlns="" id="{F9C3AD8B-F1EC-FCAE-5338-A2A9A6D465E2}"/>
+                <a16:creationId xmlns:a16="http://schemas.microsoft.com/office/drawing/2014/main" id="{F9C3AD8B-F1EC-FCAE-5338-A2A9A6D465E2}"/>
               </a:ext>
             </a:extLst>
           </p:cNvPr>
@@ -11415,7 +11644,7 @@
           <p:cNvPr id="21" name="Image 1" descr="preencoded.png">
             <a:extLst>
               <a:ext uri="{FF2B5EF4-FFF2-40B4-BE49-F238E27FC236}">
-                <a16:creationId xmlns:a16="http://schemas.microsoft.com/office/drawing/2014/main" xmlns="" id="{8FDCABE6-DB47-0E2B-85FF-83909E39D714}"/>
+                <a16:creationId xmlns:a16="http://schemas.microsoft.com/office/drawing/2014/main" id="{8FDCABE6-DB47-0E2B-85FF-83909E39D714}"/>
               </a:ext>
             </a:extLst>
           </p:cNvPr>
@@ -11447,7 +11676,7 @@
           <p:cNvPr id="22" name="Shape 14">
             <a:extLst>
               <a:ext uri="{FF2B5EF4-FFF2-40B4-BE49-F238E27FC236}">
-                <a16:creationId xmlns:a16="http://schemas.microsoft.com/office/drawing/2014/main" xmlns="" id="{E68F2C29-2AE3-9DEE-7853-C224996AD51C}"/>
+                <a16:creationId xmlns:a16="http://schemas.microsoft.com/office/drawing/2014/main" id="{E68F2C29-2AE3-9DEE-7853-C224996AD51C}"/>
               </a:ext>
             </a:extLst>
           </p:cNvPr>
@@ -11482,7 +11711,7 @@
           <p:cNvPr id="23" name="Text 15">
             <a:extLst>
               <a:ext uri="{FF2B5EF4-FFF2-40B4-BE49-F238E27FC236}">
-                <a16:creationId xmlns:a16="http://schemas.microsoft.com/office/drawing/2014/main" xmlns="" id="{0C54384D-CEB8-C8A5-A4D7-4C117408C317}"/>
+                <a16:creationId xmlns:a16="http://schemas.microsoft.com/office/drawing/2014/main" id="{0C54384D-CEB8-C8A5-A4D7-4C117408C317}"/>
               </a:ext>
             </a:extLst>
           </p:cNvPr>
@@ -11524,7 +11753,7 @@
           <p:cNvPr id="24" name="Text 16">
             <a:extLst>
               <a:ext uri="{FF2B5EF4-FFF2-40B4-BE49-F238E27FC236}">
-                <a16:creationId xmlns:a16="http://schemas.microsoft.com/office/drawing/2014/main" xmlns="" id="{D9B0A7A7-DCD6-F560-4057-C3511816D05F}"/>
+                <a16:creationId xmlns:a16="http://schemas.microsoft.com/office/drawing/2014/main" id="{D9B0A7A7-DCD6-F560-4057-C3511816D05F}"/>
               </a:ext>
             </a:extLst>
           </p:cNvPr>
@@ -11574,7 +11803,7 @@
           <p:cNvPr id="25" name="Text 17">
             <a:extLst>
               <a:ext uri="{FF2B5EF4-FFF2-40B4-BE49-F238E27FC236}">
-                <a16:creationId xmlns:a16="http://schemas.microsoft.com/office/drawing/2014/main" xmlns="" id="{1CB54C08-6656-D789-CFEB-E5CC8577CFF9}"/>
+                <a16:creationId xmlns:a16="http://schemas.microsoft.com/office/drawing/2014/main" id="{1CB54C08-6656-D789-CFEB-E5CC8577CFF9}"/>
               </a:ext>
             </a:extLst>
           </p:cNvPr>
@@ -11624,7 +11853,7 @@
           <p:cNvPr id="26" name="Shape 18">
             <a:extLst>
               <a:ext uri="{FF2B5EF4-FFF2-40B4-BE49-F238E27FC236}">
-                <a16:creationId xmlns:a16="http://schemas.microsoft.com/office/drawing/2014/main" xmlns="" id="{F51D1AD7-FDBB-D88C-3341-0CE21E68991E}"/>
+                <a16:creationId xmlns:a16="http://schemas.microsoft.com/office/drawing/2014/main" id="{F51D1AD7-FDBB-D88C-3341-0CE21E68991E}"/>
               </a:ext>
             </a:extLst>
           </p:cNvPr>
@@ -11662,7 +11891,7 @@
           <p:cNvPr id="27" name="Image 2" descr="preencoded.png">
             <a:extLst>
               <a:ext uri="{FF2B5EF4-FFF2-40B4-BE49-F238E27FC236}">
-                <a16:creationId xmlns:a16="http://schemas.microsoft.com/office/drawing/2014/main" xmlns="" id="{6693F5CB-F6C3-0AE6-8ADA-71F303FD94AA}"/>
+                <a16:creationId xmlns:a16="http://schemas.microsoft.com/office/drawing/2014/main" id="{6693F5CB-F6C3-0AE6-8ADA-71F303FD94AA}"/>
               </a:ext>
             </a:extLst>
           </p:cNvPr>
@@ -11691,7 +11920,7 @@
           <p:cNvPr id="29" name="Text 20">
             <a:extLst>
               <a:ext uri="{FF2B5EF4-FFF2-40B4-BE49-F238E27FC236}">
-                <a16:creationId xmlns:a16="http://schemas.microsoft.com/office/drawing/2014/main" xmlns="" id="{F4B10A3A-3BE6-6421-CF3C-1D084B71FF90}"/>
+                <a16:creationId xmlns:a16="http://schemas.microsoft.com/office/drawing/2014/main" id="{F4B10A3A-3BE6-6421-CF3C-1D084B71FF90}"/>
               </a:ext>
             </a:extLst>
           </p:cNvPr>
@@ -11739,7 +11968,7 @@
           <p:cNvPr id="30" name="Text 21">
             <a:extLst>
               <a:ext uri="{FF2B5EF4-FFF2-40B4-BE49-F238E27FC236}">
-                <a16:creationId xmlns:a16="http://schemas.microsoft.com/office/drawing/2014/main" xmlns="" id="{742A33F4-37EB-51C1-358D-868DC7F80D44}"/>
+                <a16:creationId xmlns:a16="http://schemas.microsoft.com/office/drawing/2014/main" id="{742A33F4-37EB-51C1-358D-868DC7F80D44}"/>
               </a:ext>
             </a:extLst>
           </p:cNvPr>
@@ -11785,7 +12014,7 @@
           <p:cNvPr id="31" name="Text 22">
             <a:extLst>
               <a:ext uri="{FF2B5EF4-FFF2-40B4-BE49-F238E27FC236}">
-                <a16:creationId xmlns:a16="http://schemas.microsoft.com/office/drawing/2014/main" xmlns="" id="{5EF65FB3-DF4F-B9D8-A501-3AAC56EC063B}"/>
+                <a16:creationId xmlns:a16="http://schemas.microsoft.com/office/drawing/2014/main" id="{5EF65FB3-DF4F-B9D8-A501-3AAC56EC063B}"/>
               </a:ext>
             </a:extLst>
           </p:cNvPr>
@@ -11831,7 +12060,7 @@
           <p:cNvPr id="3" name="Picture 2">
             <a:extLst>
               <a:ext uri="{FF2B5EF4-FFF2-40B4-BE49-F238E27FC236}">
-                <a16:creationId xmlns:a16="http://schemas.microsoft.com/office/drawing/2014/main" xmlns="" id="{90869FBF-567B-D7E6-CC4F-C11EFA4C2F0A}"/>
+                <a16:creationId xmlns:a16="http://schemas.microsoft.com/office/drawing/2014/main" id="{90869FBF-567B-D7E6-CC4F-C11EFA4C2F0A}"/>
               </a:ext>
             </a:extLst>
           </p:cNvPr>
@@ -11861,7 +12090,7 @@
           <p:cNvPr id="5" name="Picture 4">
             <a:extLst>
               <a:ext uri="{FF2B5EF4-FFF2-40B4-BE49-F238E27FC236}">
-                <a16:creationId xmlns:a16="http://schemas.microsoft.com/office/drawing/2014/main" xmlns="" id="{8DA114F2-7922-77CF-217D-669A96B3E5C2}"/>
+                <a16:creationId xmlns:a16="http://schemas.microsoft.com/office/drawing/2014/main" id="{8DA114F2-7922-77CF-217D-669A96B3E5C2}"/>
               </a:ext>
             </a:extLst>
           </p:cNvPr>
@@ -11891,7 +12120,7 @@
           <p:cNvPr id="11" name="Picture 10">
             <a:extLst>
               <a:ext uri="{FF2B5EF4-FFF2-40B4-BE49-F238E27FC236}">
-                <a16:creationId xmlns:a16="http://schemas.microsoft.com/office/drawing/2014/main" xmlns="" id="{B37BDF62-7B21-B098-EF68-CCE3ED824751}"/>
+                <a16:creationId xmlns:a16="http://schemas.microsoft.com/office/drawing/2014/main" id="{B37BDF62-7B21-B098-EF68-CCE3ED824751}"/>
               </a:ext>
             </a:extLst>
           </p:cNvPr>

</xml_diff>